<commit_message>
Embed publication-grade methodological roadmap into main paper and master thesis, update defense slides to 0 collision
</commit_message>
<xml_diff>
--- a/学术答辩PPT_简约大气优化版.pptx
+++ b/学术答辩PPT_简约大气优化版.pptx
@@ -4331,21 +4331,31 @@
           <a:p>
             <a:pPr>
               <a:lnSpc>
-                <a:spcPct val="122000"/>
-              </a:lnSpc>
-            </a:pPr>
-            <a:r>
-              <a:rPr sz="1100" b="1">
+                <a:spcPct val="115000"/>
+              </a:lnSpc>
+            </a:pPr>
+            <a:r>
+              <a:rPr sz="1080" b="1">
                 <a:solidFill>
                   <a:srgbClr val="1E3A8A"/>
                 </a:solidFill>
                 <a:latin typeface="Segoe UI"/>
                 <a:ea typeface="Microsoft YaHei"/>
               </a:rPr>
-              <a:t>【工作量总体自评】  </a:t>
-            </a:r>
-            <a:r>
-              <a:rPr sz="980">
+              <a:t>【工作量总体自评】</a:t>
+            </a:r>
+          </a:p>
+          <a:p>
+            <a:pPr>
+              <a:lnSpc>
+                <a:spcPct val="118000"/>
+              </a:lnSpc>
+              <a:spcBef>
+                <a:spcPts val="300"/>
+              </a:spcBef>
+            </a:pPr>
+            <a:r>
+              <a:rPr sz="950">
                 <a:solidFill>
                   <a:srgbClr val="334155"/>
                 </a:solidFill>
@@ -5361,8 +5371,8 @@
         </p:nvSpPr>
         <p:spPr>
           <a:xfrm>
-            <a:off x="720000" y="1404000"/>
-            <a:ext cx="5040000" cy="666000"/>
+            <a:off x="720000" y="1386000"/>
+            <a:ext cx="5040000" cy="4860000"/>
           </a:xfrm>
           <a:prstGeom prst="roundRect">
             <a:avLst>
@@ -5387,16 +5397,75 @@
           </a:p>
         </p:txBody>
       </p:sp>
-      <p:sp>
-        <p:nvSpPr>
-          <p:cNvPr id="9" name="TextBox 8"/>
+      <p:pic>
+        <p:nvPicPr>
+          <p:cNvPr id="9" name="Picture 8" descr="fig0_technical_roadmap.png"/>
+          <p:cNvPicPr>
+            <a:picLocks noChangeAspect="1"/>
+          </p:cNvPicPr>
+          <p:nvPr/>
+        </p:nvPicPr>
+        <p:blipFill>
+          <a:blip r:embed="rId7"/>
+          <a:stretch>
+            <a:fillRect/>
+          </a:stretch>
+        </p:blipFill>
+        <p:spPr>
+          <a:xfrm>
+            <a:off x="1369639" y="1458000"/>
+            <a:ext cx="3740720" cy="4716000"/>
+          </a:xfrm>
+          <a:prstGeom prst="rect">
+            <a:avLst/>
+          </a:prstGeom>
+          <a:effectLst/>
+        </p:spPr>
+      </p:pic>
+      <p:sp>
+        <p:nvSpPr>
+          <p:cNvPr id="10" name="Rounded Rectangle 9"/>
+          <p:cNvSpPr/>
+          <p:nvPr/>
+        </p:nvSpPr>
+        <p:spPr>
+          <a:xfrm>
+            <a:off x="6228000" y="954000"/>
+            <a:ext cx="5425200" cy="5472000"/>
+          </a:xfrm>
+          <a:prstGeom prst="roundRect">
+            <a:avLst>
+              <a:gd name="adj" fmla="val 2000"/>
+            </a:avLst>
+          </a:prstGeom>
+          <a:solidFill>
+            <a:srgbClr val="F8FAFC"/>
+          </a:solidFill>
+          <a:ln w="12700">
+            <a:solidFill>
+              <a:srgbClr val="E2E8F0"/>
+            </a:solidFill>
+          </a:ln>
+          <a:effectLst/>
+        </p:spPr>
+        <p:txBody>
+          <a:bodyPr rtlCol="0" anchor="ctr"/>
+          <a:lstStyle/>
+          <a:p>
+            <a:pPr algn="ctr"/>
+          </a:p>
+        </p:txBody>
+      </p:sp>
+      <p:sp>
+        <p:nvSpPr>
+          <p:cNvPr id="11" name="TextBox 10"/>
           <p:cNvSpPr txBox="1"/>
           <p:nvPr/>
         </p:nvSpPr>
         <p:spPr>
           <a:xfrm>
-            <a:off x="791999" y="1458000"/>
-            <a:ext cx="4896001" cy="558000"/>
+            <a:off x="6444000" y="1116000"/>
+            <a:ext cx="4993200" cy="216000"/>
           </a:xfrm>
           <a:prstGeom prst="rect">
             <a:avLst/>
@@ -5405,61 +5474,34 @@
           <a:effectLst/>
         </p:spPr>
         <p:txBody>
-          <a:bodyPr wrap="square">
+          <a:bodyPr wrap="none">
             <a:spAutoFit/>
           </a:bodyPr>
           <a:lstStyle/>
           <a:p>
             <a:r>
-              <a:rPr sz="1050" b="1">
-                <a:solidFill>
-                  <a:srgbClr val="1E293B"/>
-                </a:solidFill>
-                <a:latin typeface="Segoe UI"/>
-                <a:ea typeface="Microsoft YaHei"/>
-              </a:rPr>
-              <a:t>第一章 绪论：监测困境与问题提出</a:t>
-            </a:r>
-            <a:r>
-              <a:rPr sz="950" b="1">
-                <a:solidFill>
-                  <a:srgbClr val="2563EB"/>
-                </a:solidFill>
-                <a:latin typeface="Segoe UI"/>
-                <a:ea typeface="Microsoft YaHei"/>
-              </a:rPr>
-              <a:t>  [12~14 页 (已完成)]</a:t>
-            </a:r>
-          </a:p>
-          <a:p>
-            <a:pPr>
-              <a:lnSpc>
-                <a:spcPct val="115000"/>
-              </a:lnSpc>
-            </a:pPr>
-            <a:r>
-              <a:rPr sz="880">
-                <a:solidFill>
-                  <a:srgbClr val="64748B"/>
-                </a:solidFill>
-                <a:latin typeface="Segoe UI"/>
-                <a:ea typeface="Microsoft YaHei"/>
-              </a:rPr>
-              <a:t>公卫监测悖论、EpiEstim 与 Parag 信息极限文献演进、推断目标分化设问</a:t>
-            </a:r>
-          </a:p>
-        </p:txBody>
-      </p:sp>
-      <p:sp>
-        <p:nvSpPr>
-          <p:cNvPr id="10" name="Rounded Rectangle 9"/>
+              <a:rPr sz="1400" b="1">
+                <a:solidFill>
+                  <a:srgbClr val="1E3A8A"/>
+                </a:solidFill>
+                <a:latin typeface="Segoe UI"/>
+                <a:ea typeface="Microsoft YaHei"/>
+              </a:rPr>
+              <a:t>中期完成度指标与核心学术储备</a:t>
+            </a:r>
+          </a:p>
+        </p:txBody>
+      </p:sp>
+      <p:sp>
+        <p:nvSpPr>
+          <p:cNvPr id="12" name="Rounded Rectangle 11"/>
           <p:cNvSpPr/>
           <p:nvPr/>
         </p:nvSpPr>
         <p:spPr>
           <a:xfrm>
-            <a:off x="720000" y="2106000"/>
-            <a:ext cx="5040000" cy="666000"/>
+            <a:off x="6408000" y="1404000"/>
+            <a:ext cx="5065200" cy="864000"/>
           </a:xfrm>
           <a:prstGeom prst="roundRect">
             <a:avLst>
@@ -5486,14 +5528,14 @@
       </p:sp>
       <p:sp>
         <p:nvSpPr>
-          <p:cNvPr id="11" name="TextBox 10"/>
+          <p:cNvPr id="13" name="TextBox 12"/>
           <p:cNvSpPr txBox="1"/>
           <p:nvPr/>
         </p:nvSpPr>
         <p:spPr>
           <a:xfrm>
-            <a:off x="791999" y="2160000"/>
-            <a:ext cx="4896001" cy="558000"/>
+            <a:off x="6516000" y="1476000"/>
+            <a:ext cx="4849200" cy="720000"/>
           </a:xfrm>
           <a:prstGeom prst="rect">
             <a:avLst/>
@@ -5508,55 +5550,58 @@
           <a:lstStyle/>
           <a:p>
             <a:r>
-              <a:rPr sz="1050" b="1">
+              <a:rPr sz="1100" b="1">
                 <a:solidFill>
                   <a:srgbClr val="1E293B"/>
                 </a:solidFill>
                 <a:latin typeface="Segoe UI"/>
                 <a:ea typeface="Microsoft YaHei"/>
               </a:rPr>
-              <a:t>第二章 动力学建模与观测机制</a:t>
-            </a:r>
-            <a:r>
-              <a:rPr sz="950" b="1">
-                <a:solidFill>
-                  <a:srgbClr val="2563EB"/>
-                </a:solidFill>
-                <a:latin typeface="Segoe UI"/>
-                <a:ea typeface="Microsoft YaHei"/>
-              </a:rPr>
-              <a:t>  [10~12 页 (已完成)]</a:t>
+              <a:t>理论推导闭环：</a:t>
+            </a:r>
+            <a:r>
+              <a:rPr sz="1150" b="1">
+                <a:solidFill>
+                  <a:srgbClr val="1E3A8A"/>
+                </a:solidFill>
+                <a:latin typeface="Segoe UI"/>
+                <a:ea typeface="Microsoft YaHei"/>
+              </a:rPr>
+              <a:t>6 大命题 + 1 核心推论</a:t>
             </a:r>
           </a:p>
           <a:p>
             <a:pPr>
               <a:lnSpc>
-                <a:spcPct val="115000"/>
-              </a:lnSpc>
-            </a:pPr>
-            <a:r>
-              <a:rPr sz="880">
-                <a:solidFill>
-                  <a:srgbClr val="64748B"/>
-                </a:solidFill>
-                <a:latin typeface="Segoe UI"/>
-                <a:ea typeface="Microsoft YaHei"/>
-              </a:rPr>
-              <a:t>Gamma-Poisson 混合负二项、二项报告抽稀、PGF 复合闭合与成功概率顿悟</a:t>
-            </a:r>
-          </a:p>
-        </p:txBody>
-      </p:sp>
-      <p:sp>
-        <p:nvSpPr>
-          <p:cNvPr id="12" name="Rounded Rectangle 11"/>
+                <a:spcPct val="120000"/>
+              </a:lnSpc>
+              <a:spcBef>
+                <a:spcPts val="300"/>
+              </a:spcBef>
+            </a:pPr>
+            <a:r>
+              <a:rPr sz="919">
+                <a:solidFill>
+                  <a:srgbClr val="334155"/>
+                </a:solidFill>
+                <a:latin typeface="Segoe UI"/>
+                <a:ea typeface="Microsoft YaHei"/>
+              </a:rPr>
+              <a:t>PGF 复合封闭、Score 方程、无偏性验证、Fisher 信息双套算法、Cochran 对偶全闭式解</a:t>
+            </a:r>
+          </a:p>
+        </p:txBody>
+      </p:sp>
+      <p:sp>
+        <p:nvSpPr>
+          <p:cNvPr id="14" name="Rounded Rectangle 13"/>
           <p:cNvSpPr/>
           <p:nvPr/>
         </p:nvSpPr>
         <p:spPr>
           <a:xfrm>
-            <a:off x="720000" y="2808000"/>
-            <a:ext cx="5040000" cy="666000"/>
+            <a:off x="6408000" y="2321999"/>
+            <a:ext cx="5065200" cy="864000"/>
           </a:xfrm>
           <a:prstGeom prst="roundRect">
             <a:avLst>
@@ -5583,14 +5628,14 @@
       </p:sp>
       <p:sp>
         <p:nvSpPr>
-          <p:cNvPr id="13" name="TextBox 12"/>
+          <p:cNvPr id="15" name="TextBox 14"/>
           <p:cNvSpPr txBox="1"/>
           <p:nvPr/>
         </p:nvSpPr>
         <p:spPr>
           <a:xfrm>
-            <a:off x="791999" y="2862000"/>
-            <a:ext cx="4896001" cy="558000"/>
+            <a:off x="6516000" y="2393999"/>
+            <a:ext cx="4849200" cy="720000"/>
           </a:xfrm>
           <a:prstGeom prst="rect">
             <a:avLst/>
@@ -5605,55 +5650,58 @@
           <a:lstStyle/>
           <a:p>
             <a:r>
-              <a:rPr sz="1050" b="1">
+              <a:rPr sz="1100" b="1">
                 <a:solidFill>
                   <a:srgbClr val="1E293B"/>
                 </a:solidFill>
                 <a:latin typeface="Segoe UI"/>
                 <a:ea typeface="Microsoft YaHei"/>
               </a:rPr>
-              <a:t>第三章 渐近推断与运筹优化设计</a:t>
-            </a:r>
-            <a:r>
-              <a:rPr sz="950" b="1">
-                <a:solidFill>
-                  <a:srgbClr val="2563EB"/>
-                </a:solidFill>
-                <a:latin typeface="Segoe UI"/>
-                <a:ea typeface="Microsoft YaHei"/>
-              </a:rPr>
-              <a:t>  [18~20 页 (已完成)]</a:t>
+              <a:t>真实实证样本：</a:t>
+            </a:r>
+            <a:r>
+              <a:rPr sz="1150" b="1">
+                <a:solidFill>
+                  <a:srgbClr val="1E3A8A"/>
+                </a:solidFill>
+                <a:latin typeface="Segoe UI"/>
+                <a:ea typeface="Microsoft YaHei"/>
+              </a:rPr>
+              <a:t>16,218 原始记录</a:t>
             </a:r>
           </a:p>
           <a:p>
             <a:pPr>
               <a:lnSpc>
-                <a:spcPct val="115000"/>
-              </a:lnSpc>
-            </a:pPr>
-            <a:r>
-              <a:rPr sz="880">
-                <a:solidFill>
-                  <a:srgbClr val="64748B"/>
-                </a:solidFill>
-                <a:latin typeface="Segoe UI"/>
-                <a:ea typeface="Microsoft YaHei"/>
-              </a:rPr>
-              <a:t>命题 1~4、CRLB、仿射分解 v_R+A/m、监测杠杆非对称性、Cochran 对偶</a:t>
-            </a:r>
-          </a:p>
-        </p:txBody>
-      </p:sp>
-      <p:sp>
-        <p:nvSpPr>
-          <p:cNvPr id="14" name="Rounded Rectangle 13"/>
+                <a:spcPct val="120000"/>
+              </a:lnSpc>
+              <a:spcBef>
+                <a:spcPts val="300"/>
+              </a:spcBef>
+            </a:pPr>
+            <a:r>
+              <a:rPr sz="919">
+                <a:solidFill>
+                  <a:srgbClr val="334155"/>
+                </a:solidFill>
+                <a:latin typeface="Segoe UI"/>
+                <a:ea typeface="Microsoft YaHei"/>
+              </a:rPr>
+              <a:t>严格客观筛选 D_t ≥ 5，10,303 活跃周样本，三大历史制度期 6009+420+3874 算术严密闭环</a:t>
+            </a:r>
+          </a:p>
+        </p:txBody>
+      </p:sp>
+      <p:sp>
+        <p:nvSpPr>
+          <p:cNvPr id="16" name="Rounded Rectangle 15"/>
           <p:cNvSpPr/>
           <p:nvPr/>
         </p:nvSpPr>
         <p:spPr>
           <a:xfrm>
-            <a:off x="720000" y="3510000"/>
-            <a:ext cx="5040000" cy="666000"/>
+            <a:off x="6408000" y="3239998"/>
+            <a:ext cx="5065200" cy="864000"/>
           </a:xfrm>
           <a:prstGeom prst="roundRect">
             <a:avLst>
@@ -5680,14 +5728,14 @@
       </p:sp>
       <p:sp>
         <p:nvSpPr>
-          <p:cNvPr id="15" name="TextBox 14"/>
+          <p:cNvPr id="17" name="TextBox 16"/>
           <p:cNvSpPr txBox="1"/>
           <p:nvPr/>
         </p:nvSpPr>
         <p:spPr>
           <a:xfrm>
-            <a:off x="791999" y="3564000"/>
-            <a:ext cx="4896001" cy="558000"/>
+            <a:off x="6516000" y="3311998"/>
+            <a:ext cx="4849200" cy="720000"/>
           </a:xfrm>
           <a:prstGeom prst="rect">
             <a:avLst/>
@@ -5702,55 +5750,58 @@
           <a:lstStyle/>
           <a:p>
             <a:r>
-              <a:rPr sz="1050" b="1">
+              <a:rPr sz="1100" b="1">
                 <a:solidFill>
                   <a:srgbClr val="1E293B"/>
                 </a:solidFill>
                 <a:latin typeface="Segoe UI"/>
                 <a:ea typeface="Microsoft YaHei"/>
               </a:rPr>
-              <a:t>第四章 蒙特卡洛仿真与机制检验</a:t>
-            </a:r>
-            <a:r>
-              <a:rPr sz="950" b="1">
-                <a:solidFill>
-                  <a:srgbClr val="2563EB"/>
-                </a:solidFill>
-                <a:latin typeface="Segoe UI"/>
-                <a:ea typeface="Microsoft YaHei"/>
-              </a:rPr>
-              <a:t>  [10~12 页 (已完成)]</a:t>
+              <a:t>回归校验套件：</a:t>
+            </a:r>
+            <a:r>
+              <a:rPr sz="1150" b="1">
+                <a:solidFill>
+                  <a:srgbClr val="1E3A8A"/>
+                </a:solidFill>
+                <a:latin typeface="Segoe UI"/>
+                <a:ea typeface="Microsoft YaHei"/>
+              </a:rPr>
+              <a:t>213 项全域数字检验</a:t>
             </a:r>
           </a:p>
           <a:p>
             <a:pPr>
               <a:lnSpc>
-                <a:spcPct val="115000"/>
-              </a:lnSpc>
-            </a:pPr>
-            <a:r>
-              <a:rPr sz="880">
-                <a:solidFill>
-                  <a:srgbClr val="64748B"/>
-                </a:solidFill>
-                <a:latin typeface="Segoe UI"/>
-                <a:ea typeface="Microsoft YaHei"/>
-              </a:rPr>
-              <a:t>命题 5~6、Wald 失真与离散功效锯齿、更新过程预测分解式 (29) 双口径</a:t>
-            </a:r>
-          </a:p>
-        </p:txBody>
-      </p:sp>
-      <p:sp>
-        <p:nvSpPr>
-          <p:cNvPr id="16" name="Rounded Rectangle 15"/>
+                <a:spcPct val="120000"/>
+              </a:lnSpc>
+              <a:spcBef>
+                <a:spcPts val="300"/>
+              </a:spcBef>
+            </a:pPr>
+            <a:r>
+              <a:rPr sz="919">
+                <a:solidFill>
+                  <a:srgbClr val="334155"/>
+                </a:solidFill>
+                <a:latin typeface="Segoe UI"/>
+                <a:ea typeface="Microsoft YaHei"/>
+              </a:rPr>
+              <a:t>包含多重聚类 Bootstrap CI [-2.33, 0.59]、仿射参数 22.6 等全量测试 100% 绿色通过</a:t>
+            </a:r>
+          </a:p>
+        </p:txBody>
+      </p:sp>
+      <p:sp>
+        <p:nvSpPr>
+          <p:cNvPr id="18" name="Rounded Rectangle 17"/>
           <p:cNvSpPr/>
           <p:nvPr/>
         </p:nvSpPr>
         <p:spPr>
           <a:xfrm>
-            <a:off x="720000" y="4212000"/>
-            <a:ext cx="5040000" cy="666000"/>
+            <a:off x="6408000" y="4157997"/>
+            <a:ext cx="5065200" cy="864000"/>
           </a:xfrm>
           <a:prstGeom prst="roundRect">
             <a:avLst>
@@ -5777,14 +5828,14 @@
       </p:sp>
       <p:sp>
         <p:nvSpPr>
-          <p:cNvPr id="17" name="TextBox 16"/>
+          <p:cNvPr id="19" name="TextBox 18"/>
           <p:cNvSpPr txBox="1"/>
           <p:nvPr/>
         </p:nvSpPr>
         <p:spPr>
           <a:xfrm>
-            <a:off x="791999" y="4266000"/>
-            <a:ext cx="4896001" cy="558000"/>
+            <a:off x="6516000" y="4229997"/>
+            <a:ext cx="4849200" cy="720000"/>
           </a:xfrm>
           <a:prstGeom prst="rect">
             <a:avLst/>
@@ -5799,385 +5850,24 @@
           <a:lstStyle/>
           <a:p>
             <a:r>
-              <a:rPr sz="1050" b="1">
+              <a:rPr sz="1100" b="1">
                 <a:solidFill>
                   <a:srgbClr val="1E293B"/>
                 </a:solidFill>
                 <a:latin typeface="Segoe UI"/>
                 <a:ea typeface="Microsoft YaHei"/>
               </a:rPr>
-              <a:t>第五章 全美流感住院大数据实证</a:t>
-            </a:r>
-            <a:r>
-              <a:rPr sz="950" b="1">
-                <a:solidFill>
-                  <a:srgbClr val="2563EB"/>
-                </a:solidFill>
-                <a:latin typeface="Segoe UI"/>
-                <a:ea typeface="Microsoft YaHei"/>
-              </a:rPr>
-              <a:t>  [16~18 页 (已完成)]</a:t>
-            </a:r>
-          </a:p>
-          <a:p>
-            <a:pPr>
-              <a:lnSpc>
-                <a:spcPct val="115000"/>
-              </a:lnSpc>
-            </a:pPr>
-            <a:r>
-              <a:rPr sz="880">
-                <a:solidFill>
-                  <a:srgbClr val="64748B"/>
-                </a:solidFill>
-                <a:latin typeface="Segoe UI"/>
-                <a:ea typeface="Microsoft YaHei"/>
-              </a:rPr>
-              <a:t>NHSN 10,303 闭环样本、FGLS 拟合、达峰期 88.9% 偏差正交分解、制度冲击</a:t>
-            </a:r>
-          </a:p>
-        </p:txBody>
-      </p:sp>
-      <p:sp>
-        <p:nvSpPr>
-          <p:cNvPr id="18" name="Rounded Rectangle 17"/>
-          <p:cNvSpPr/>
-          <p:nvPr/>
-        </p:nvSpPr>
-        <p:spPr>
-          <a:xfrm>
-            <a:off x="720000" y="4914000"/>
-            <a:ext cx="5040000" cy="666000"/>
-          </a:xfrm>
-          <a:prstGeom prst="roundRect">
-            <a:avLst>
-              <a:gd name="adj" fmla="val 2000"/>
-            </a:avLst>
-          </a:prstGeom>
-          <a:solidFill>
-            <a:srgbClr val="FFFFFF"/>
-          </a:solidFill>
-          <a:ln w="12700">
-            <a:solidFill>
-              <a:srgbClr val="E2E8F0"/>
-            </a:solidFill>
-          </a:ln>
-          <a:effectLst/>
-        </p:spPr>
-        <p:txBody>
-          <a:bodyPr rtlCol="0" anchor="ctr"/>
-          <a:lstStyle/>
-          <a:p>
-            <a:pPr algn="ctr"/>
-          </a:p>
-        </p:txBody>
-      </p:sp>
-      <p:sp>
-        <p:nvSpPr>
-          <p:cNvPr id="19" name="TextBox 18"/>
-          <p:cNvSpPr txBox="1"/>
-          <p:nvPr/>
-        </p:nvSpPr>
-        <p:spPr>
-          <a:xfrm>
-            <a:off x="791999" y="4968000"/>
-            <a:ext cx="4896001" cy="558000"/>
-          </a:xfrm>
-          <a:prstGeom prst="rect">
-            <a:avLst/>
-          </a:prstGeom>
-          <a:noFill/>
-          <a:effectLst/>
-        </p:spPr>
-        <p:txBody>
-          <a:bodyPr wrap="square">
-            <a:spAutoFit/>
-          </a:bodyPr>
-          <a:lstStyle/>
-          <a:p>
-            <a:r>
-              <a:rPr sz="1050" b="1">
-                <a:solidFill>
-                  <a:srgbClr val="1E293B"/>
-                </a:solidFill>
-                <a:latin typeface="Segoe UI"/>
-                <a:ea typeface="Microsoft YaHei"/>
-              </a:rPr>
-              <a:t>第六章 跨模型与跨病种外部验证</a:t>
-            </a:r>
-            <a:r>
-              <a:rPr sz="950" b="1">
-                <a:solidFill>
-                  <a:srgbClr val="2563EB"/>
-                </a:solidFill>
-                <a:latin typeface="Segoe UI"/>
-                <a:ea typeface="Microsoft YaHei"/>
-              </a:rPr>
-              <a:t>  [8~10 页 (已完成)]</a:t>
-            </a:r>
-          </a:p>
-          <a:p>
-            <a:pPr>
-              <a:lnSpc>
-                <a:spcPct val="115000"/>
-              </a:lnSpc>
-            </a:pPr>
-            <a:r>
-              <a:rPr sz="880">
-                <a:solidFill>
-                  <a:srgbClr val="64748B"/>
-                </a:solidFill>
-                <a:latin typeface="Segoe UI"/>
-                <a:ea typeface="Microsoft YaHei"/>
-              </a:rPr>
-              <a:t>CDC FluSight 集成预测 (偏差降至 15.5%)、欧洲 11 国 COVID-19 扩展验证</a:t>
-            </a:r>
-          </a:p>
-        </p:txBody>
-      </p:sp>
-      <p:sp>
-        <p:nvSpPr>
-          <p:cNvPr id="20" name="Rounded Rectangle 19"/>
-          <p:cNvSpPr/>
-          <p:nvPr/>
-        </p:nvSpPr>
-        <p:spPr>
-          <a:xfrm>
-            <a:off x="720000" y="5616000"/>
-            <a:ext cx="5040000" cy="666000"/>
-          </a:xfrm>
-          <a:prstGeom prst="roundRect">
-            <a:avLst>
-              <a:gd name="adj" fmla="val 2000"/>
-            </a:avLst>
-          </a:prstGeom>
-          <a:solidFill>
-            <a:srgbClr val="FFFFFF"/>
-          </a:solidFill>
-          <a:ln w="12700">
-            <a:solidFill>
-              <a:srgbClr val="E2E8F0"/>
-            </a:solidFill>
-          </a:ln>
-          <a:effectLst/>
-        </p:spPr>
-        <p:txBody>
-          <a:bodyPr rtlCol="0" anchor="ctr"/>
-          <a:lstStyle/>
-          <a:p>
-            <a:pPr algn="ctr"/>
-          </a:p>
-        </p:txBody>
-      </p:sp>
-      <p:sp>
-        <p:nvSpPr>
-          <p:cNvPr id="21" name="TextBox 20"/>
-          <p:cNvSpPr txBox="1"/>
-          <p:nvPr/>
-        </p:nvSpPr>
-        <p:spPr>
-          <a:xfrm>
-            <a:off x="791999" y="5670000"/>
-            <a:ext cx="4896001" cy="558000"/>
-          </a:xfrm>
-          <a:prstGeom prst="rect">
-            <a:avLst/>
-          </a:prstGeom>
-          <a:noFill/>
-          <a:effectLst/>
-        </p:spPr>
-        <p:txBody>
-          <a:bodyPr wrap="square">
-            <a:spAutoFit/>
-          </a:bodyPr>
-          <a:lstStyle/>
-          <a:p>
-            <a:r>
-              <a:rPr sz="1050" b="1">
-                <a:solidFill>
-                  <a:srgbClr val="1E293B"/>
-                </a:solidFill>
-                <a:latin typeface="Segoe UI"/>
-                <a:ea typeface="Microsoft YaHei"/>
-              </a:rPr>
-              <a:t>第七章 资源优化建议与研究展望</a:t>
-            </a:r>
-            <a:r>
-              <a:rPr sz="950" b="1">
-                <a:solidFill>
-                  <a:srgbClr val="2563EB"/>
-                </a:solidFill>
-                <a:latin typeface="Segoe UI"/>
-                <a:ea typeface="Microsoft YaHei"/>
-              </a:rPr>
-              <a:t>  [4~5 页 (成稿中)]</a:t>
-            </a:r>
-          </a:p>
-          <a:p>
-            <a:pPr>
-              <a:lnSpc>
-                <a:spcPct val="115000"/>
-              </a:lnSpc>
-            </a:pPr>
-            <a:r>
-              <a:rPr sz="880">
-                <a:solidFill>
-                  <a:srgbClr val="64748B"/>
-                </a:solidFill>
-                <a:latin typeface="Segoe UI"/>
-                <a:ea typeface="Microsoft YaHei"/>
-              </a:rPr>
-              <a:t>两阶段监测资源分配策略矩阵、双轨主动追踪队列识别设计、结论总结</a:t>
-            </a:r>
-          </a:p>
-        </p:txBody>
-      </p:sp>
-      <p:sp>
-        <p:nvSpPr>
-          <p:cNvPr id="22" name="Rounded Rectangle 21"/>
-          <p:cNvSpPr/>
-          <p:nvPr/>
-        </p:nvSpPr>
-        <p:spPr>
-          <a:xfrm>
-            <a:off x="6228000" y="954000"/>
-            <a:ext cx="5425200" cy="5472000"/>
-          </a:xfrm>
-          <a:prstGeom prst="roundRect">
-            <a:avLst>
-              <a:gd name="adj" fmla="val 2000"/>
-            </a:avLst>
-          </a:prstGeom>
-          <a:solidFill>
-            <a:srgbClr val="F8FAFC"/>
-          </a:solidFill>
-          <a:ln w="12700">
-            <a:solidFill>
-              <a:srgbClr val="E2E8F0"/>
-            </a:solidFill>
-          </a:ln>
-          <a:effectLst/>
-        </p:spPr>
-        <p:txBody>
-          <a:bodyPr rtlCol="0" anchor="ctr"/>
-          <a:lstStyle/>
-          <a:p>
-            <a:pPr algn="ctr"/>
-          </a:p>
-        </p:txBody>
-      </p:sp>
-      <p:sp>
-        <p:nvSpPr>
-          <p:cNvPr id="23" name="TextBox 22"/>
-          <p:cNvSpPr txBox="1"/>
-          <p:nvPr/>
-        </p:nvSpPr>
-        <p:spPr>
-          <a:xfrm>
-            <a:off x="6444000" y="1116000"/>
-            <a:ext cx="4993200" cy="216000"/>
-          </a:xfrm>
-          <a:prstGeom prst="rect">
-            <a:avLst/>
-          </a:prstGeom>
-          <a:noFill/>
-          <a:effectLst/>
-        </p:spPr>
-        <p:txBody>
-          <a:bodyPr wrap="none">
-            <a:spAutoFit/>
-          </a:bodyPr>
-          <a:lstStyle/>
-          <a:p>
-            <a:r>
-              <a:rPr sz="1400" b="1">
+              <a:t>前期成果基础：</a:t>
+            </a:r>
+            <a:r>
+              <a:rPr sz="1150" b="1">
                 <a:solidFill>
                   <a:srgbClr val="1E3A8A"/>
                 </a:solidFill>
                 <a:latin typeface="Segoe UI"/>
                 <a:ea typeface="Microsoft YaHei"/>
               </a:rPr>
-              <a:t>中期完成度指标与核心学术储备</a:t>
-            </a:r>
-          </a:p>
-        </p:txBody>
-      </p:sp>
-      <p:sp>
-        <p:nvSpPr>
-          <p:cNvPr id="24" name="Rounded Rectangle 23"/>
-          <p:cNvSpPr/>
-          <p:nvPr/>
-        </p:nvSpPr>
-        <p:spPr>
-          <a:xfrm>
-            <a:off x="6408000" y="1404000"/>
-            <a:ext cx="5065200" cy="864000"/>
-          </a:xfrm>
-          <a:prstGeom prst="roundRect">
-            <a:avLst>
-              <a:gd name="adj" fmla="val 2000"/>
-            </a:avLst>
-          </a:prstGeom>
-          <a:solidFill>
-            <a:srgbClr val="FFFFFF"/>
-          </a:solidFill>
-          <a:ln w="12700">
-            <a:solidFill>
-              <a:srgbClr val="E2E8F0"/>
-            </a:solidFill>
-          </a:ln>
-          <a:effectLst/>
-        </p:spPr>
-        <p:txBody>
-          <a:bodyPr rtlCol="0" anchor="ctr"/>
-          <a:lstStyle/>
-          <a:p>
-            <a:pPr algn="ctr"/>
-          </a:p>
-        </p:txBody>
-      </p:sp>
-      <p:sp>
-        <p:nvSpPr>
-          <p:cNvPr id="25" name="TextBox 24"/>
-          <p:cNvSpPr txBox="1"/>
-          <p:nvPr/>
-        </p:nvSpPr>
-        <p:spPr>
-          <a:xfrm>
-            <a:off x="6516000" y="1476000"/>
-            <a:ext cx="4849200" cy="720000"/>
-          </a:xfrm>
-          <a:prstGeom prst="rect">
-            <a:avLst/>
-          </a:prstGeom>
-          <a:noFill/>
-          <a:effectLst/>
-        </p:spPr>
-        <p:txBody>
-          <a:bodyPr wrap="square">
-            <a:spAutoFit/>
-          </a:bodyPr>
-          <a:lstStyle/>
-          <a:p>
-            <a:r>
-              <a:rPr sz="1100" b="1">
-                <a:solidFill>
-                  <a:srgbClr val="1E293B"/>
-                </a:solidFill>
-                <a:latin typeface="Segoe UI"/>
-                <a:ea typeface="Microsoft YaHei"/>
-              </a:rPr>
-              <a:t>理论推导闭环：</a:t>
-            </a:r>
-            <a:r>
-              <a:rPr sz="1150" b="1">
-                <a:solidFill>
-                  <a:srgbClr val="1E3A8A"/>
-                </a:solidFill>
-                <a:latin typeface="Segoe UI"/>
-                <a:ea typeface="Microsoft YaHei"/>
-              </a:rPr>
-              <a:t>6 大命题 + 1 核心推论</a:t>
+              <a:t>28 页高水平期刊稿</a:t>
             </a:r>
           </a:p>
           <a:p>
@@ -6197,306 +5887,6 @@
                 <a:latin typeface="Segoe UI"/>
                 <a:ea typeface="Microsoft YaHei"/>
               </a:rPr>
-              <a:t>PGF 复合封闭、Score 方程、无偏性验证、Fisher 信息双套算法、Cochran 对偶全闭式解</a:t>
-            </a:r>
-          </a:p>
-        </p:txBody>
-      </p:sp>
-      <p:sp>
-        <p:nvSpPr>
-          <p:cNvPr id="26" name="Rounded Rectangle 25"/>
-          <p:cNvSpPr/>
-          <p:nvPr/>
-        </p:nvSpPr>
-        <p:spPr>
-          <a:xfrm>
-            <a:off x="6408000" y="2321999"/>
-            <a:ext cx="5065200" cy="864000"/>
-          </a:xfrm>
-          <a:prstGeom prst="roundRect">
-            <a:avLst>
-              <a:gd name="adj" fmla="val 2000"/>
-            </a:avLst>
-          </a:prstGeom>
-          <a:solidFill>
-            <a:srgbClr val="FFFFFF"/>
-          </a:solidFill>
-          <a:ln w="12700">
-            <a:solidFill>
-              <a:srgbClr val="E2E8F0"/>
-            </a:solidFill>
-          </a:ln>
-          <a:effectLst/>
-        </p:spPr>
-        <p:txBody>
-          <a:bodyPr rtlCol="0" anchor="ctr"/>
-          <a:lstStyle/>
-          <a:p>
-            <a:pPr algn="ctr"/>
-          </a:p>
-        </p:txBody>
-      </p:sp>
-      <p:sp>
-        <p:nvSpPr>
-          <p:cNvPr id="27" name="TextBox 26"/>
-          <p:cNvSpPr txBox="1"/>
-          <p:nvPr/>
-        </p:nvSpPr>
-        <p:spPr>
-          <a:xfrm>
-            <a:off x="6516000" y="2393999"/>
-            <a:ext cx="4849200" cy="720000"/>
-          </a:xfrm>
-          <a:prstGeom prst="rect">
-            <a:avLst/>
-          </a:prstGeom>
-          <a:noFill/>
-          <a:effectLst/>
-        </p:spPr>
-        <p:txBody>
-          <a:bodyPr wrap="square">
-            <a:spAutoFit/>
-          </a:bodyPr>
-          <a:lstStyle/>
-          <a:p>
-            <a:r>
-              <a:rPr sz="1100" b="1">
-                <a:solidFill>
-                  <a:srgbClr val="1E293B"/>
-                </a:solidFill>
-                <a:latin typeface="Segoe UI"/>
-                <a:ea typeface="Microsoft YaHei"/>
-              </a:rPr>
-              <a:t>真实实证样本：</a:t>
-            </a:r>
-            <a:r>
-              <a:rPr sz="1150" b="1">
-                <a:solidFill>
-                  <a:srgbClr val="1E3A8A"/>
-                </a:solidFill>
-                <a:latin typeface="Segoe UI"/>
-                <a:ea typeface="Microsoft YaHei"/>
-              </a:rPr>
-              <a:t>16,218 原始记录</a:t>
-            </a:r>
-          </a:p>
-          <a:p>
-            <a:pPr>
-              <a:lnSpc>
-                <a:spcPct val="120000"/>
-              </a:lnSpc>
-              <a:spcBef>
-                <a:spcPts val="300"/>
-              </a:spcBef>
-            </a:pPr>
-            <a:r>
-              <a:rPr sz="919">
-                <a:solidFill>
-                  <a:srgbClr val="334155"/>
-                </a:solidFill>
-                <a:latin typeface="Segoe UI"/>
-                <a:ea typeface="Microsoft YaHei"/>
-              </a:rPr>
-              <a:t>严格客观筛选 D_t ≥ 5，10,303 活跃周样本，三大历史制度期 6009+420+3874 算术严密闭环</a:t>
-            </a:r>
-          </a:p>
-        </p:txBody>
-      </p:sp>
-      <p:sp>
-        <p:nvSpPr>
-          <p:cNvPr id="28" name="Rounded Rectangle 27"/>
-          <p:cNvSpPr/>
-          <p:nvPr/>
-        </p:nvSpPr>
-        <p:spPr>
-          <a:xfrm>
-            <a:off x="6408000" y="3239998"/>
-            <a:ext cx="5065200" cy="864000"/>
-          </a:xfrm>
-          <a:prstGeom prst="roundRect">
-            <a:avLst>
-              <a:gd name="adj" fmla="val 2000"/>
-            </a:avLst>
-          </a:prstGeom>
-          <a:solidFill>
-            <a:srgbClr val="FFFFFF"/>
-          </a:solidFill>
-          <a:ln w="12700">
-            <a:solidFill>
-              <a:srgbClr val="E2E8F0"/>
-            </a:solidFill>
-          </a:ln>
-          <a:effectLst/>
-        </p:spPr>
-        <p:txBody>
-          <a:bodyPr rtlCol="0" anchor="ctr"/>
-          <a:lstStyle/>
-          <a:p>
-            <a:pPr algn="ctr"/>
-          </a:p>
-        </p:txBody>
-      </p:sp>
-      <p:sp>
-        <p:nvSpPr>
-          <p:cNvPr id="29" name="TextBox 28"/>
-          <p:cNvSpPr txBox="1"/>
-          <p:nvPr/>
-        </p:nvSpPr>
-        <p:spPr>
-          <a:xfrm>
-            <a:off x="6516000" y="3311998"/>
-            <a:ext cx="4849200" cy="720000"/>
-          </a:xfrm>
-          <a:prstGeom prst="rect">
-            <a:avLst/>
-          </a:prstGeom>
-          <a:noFill/>
-          <a:effectLst/>
-        </p:spPr>
-        <p:txBody>
-          <a:bodyPr wrap="square">
-            <a:spAutoFit/>
-          </a:bodyPr>
-          <a:lstStyle/>
-          <a:p>
-            <a:r>
-              <a:rPr sz="1100" b="1">
-                <a:solidFill>
-                  <a:srgbClr val="1E293B"/>
-                </a:solidFill>
-                <a:latin typeface="Segoe UI"/>
-                <a:ea typeface="Microsoft YaHei"/>
-              </a:rPr>
-              <a:t>回归校验套件：</a:t>
-            </a:r>
-            <a:r>
-              <a:rPr sz="1150" b="1">
-                <a:solidFill>
-                  <a:srgbClr val="1E3A8A"/>
-                </a:solidFill>
-                <a:latin typeface="Segoe UI"/>
-                <a:ea typeface="Microsoft YaHei"/>
-              </a:rPr>
-              <a:t>213 项全域数字检验</a:t>
-            </a:r>
-          </a:p>
-          <a:p>
-            <a:pPr>
-              <a:lnSpc>
-                <a:spcPct val="120000"/>
-              </a:lnSpc>
-              <a:spcBef>
-                <a:spcPts val="300"/>
-              </a:spcBef>
-            </a:pPr>
-            <a:r>
-              <a:rPr sz="919">
-                <a:solidFill>
-                  <a:srgbClr val="334155"/>
-                </a:solidFill>
-                <a:latin typeface="Segoe UI"/>
-                <a:ea typeface="Microsoft YaHei"/>
-              </a:rPr>
-              <a:t>包含多重聚类 Bootstrap CI [-2.33, 0.59]、仿射参数 22.6 等全量测试 100% 绿色通过</a:t>
-            </a:r>
-          </a:p>
-        </p:txBody>
-      </p:sp>
-      <p:sp>
-        <p:nvSpPr>
-          <p:cNvPr id="30" name="Rounded Rectangle 29"/>
-          <p:cNvSpPr/>
-          <p:nvPr/>
-        </p:nvSpPr>
-        <p:spPr>
-          <a:xfrm>
-            <a:off x="6408000" y="4157997"/>
-            <a:ext cx="5065200" cy="864000"/>
-          </a:xfrm>
-          <a:prstGeom prst="roundRect">
-            <a:avLst>
-              <a:gd name="adj" fmla="val 2000"/>
-            </a:avLst>
-          </a:prstGeom>
-          <a:solidFill>
-            <a:srgbClr val="FFFFFF"/>
-          </a:solidFill>
-          <a:ln w="12700">
-            <a:solidFill>
-              <a:srgbClr val="E2E8F0"/>
-            </a:solidFill>
-          </a:ln>
-          <a:effectLst/>
-        </p:spPr>
-        <p:txBody>
-          <a:bodyPr rtlCol="0" anchor="ctr"/>
-          <a:lstStyle/>
-          <a:p>
-            <a:pPr algn="ctr"/>
-          </a:p>
-        </p:txBody>
-      </p:sp>
-      <p:sp>
-        <p:nvSpPr>
-          <p:cNvPr id="31" name="TextBox 30"/>
-          <p:cNvSpPr txBox="1"/>
-          <p:nvPr/>
-        </p:nvSpPr>
-        <p:spPr>
-          <a:xfrm>
-            <a:off x="6516000" y="4229997"/>
-            <a:ext cx="4849200" cy="720000"/>
-          </a:xfrm>
-          <a:prstGeom prst="rect">
-            <a:avLst/>
-          </a:prstGeom>
-          <a:noFill/>
-          <a:effectLst/>
-        </p:spPr>
-        <p:txBody>
-          <a:bodyPr wrap="square">
-            <a:spAutoFit/>
-          </a:bodyPr>
-          <a:lstStyle/>
-          <a:p>
-            <a:r>
-              <a:rPr sz="1100" b="1">
-                <a:solidFill>
-                  <a:srgbClr val="1E293B"/>
-                </a:solidFill>
-                <a:latin typeface="Segoe UI"/>
-                <a:ea typeface="Microsoft YaHei"/>
-              </a:rPr>
-              <a:t>前期成果基础：</a:t>
-            </a:r>
-            <a:r>
-              <a:rPr sz="1150" b="1">
-                <a:solidFill>
-                  <a:srgbClr val="1E3A8A"/>
-                </a:solidFill>
-                <a:latin typeface="Segoe UI"/>
-                <a:ea typeface="Microsoft YaHei"/>
-              </a:rPr>
-              <a:t>28 页高水平期刊稿</a:t>
-            </a:r>
-          </a:p>
-          <a:p>
-            <a:pPr>
-              <a:lnSpc>
-                <a:spcPct val="120000"/>
-              </a:lnSpc>
-              <a:spcBef>
-                <a:spcPts val="300"/>
-              </a:spcBef>
-            </a:pPr>
-            <a:r>
-              <a:rPr sz="919">
-                <a:solidFill>
-                  <a:srgbClr val="334155"/>
-                </a:solidFill>
-                <a:latin typeface="Segoe UI"/>
-                <a:ea typeface="Microsoft YaHei"/>
-              </a:rPr>
               <a:t>小论文全文定稿，获高分审稿评价；大论文框架已成型，已具备 80 页展开的坚实基石</a:t>
             </a:r>
           </a:p>
@@ -6504,7 +5894,7 @@
       </p:sp>
       <p:sp>
         <p:nvSpPr>
-          <p:cNvPr id="32" name="Rounded Rectangle 31"/>
+          <p:cNvPr id="20" name="Rounded Rectangle 19"/>
           <p:cNvSpPr/>
           <p:nvPr/>
         </p:nvSpPr>
@@ -6538,7 +5928,7 @@
       </p:sp>
       <p:sp>
         <p:nvSpPr>
-          <p:cNvPr id="33" name="TextBox 32"/>
+          <p:cNvPr id="21" name="TextBox 20"/>
           <p:cNvSpPr txBox="1"/>
           <p:nvPr/>
         </p:nvSpPr>
@@ -6561,21 +5951,31 @@
           <a:p>
             <a:pPr>
               <a:lnSpc>
-                <a:spcPct val="122000"/>
-              </a:lnSpc>
-            </a:pPr>
-            <a:r>
-              <a:rPr sz="1100" b="1">
+                <a:spcPct val="115000"/>
+              </a:lnSpc>
+            </a:pPr>
+            <a:r>
+              <a:rPr sz="1080" b="1">
                 <a:solidFill>
                   <a:srgbClr val="1E3A8A"/>
                 </a:solidFill>
                 <a:latin typeface="Segoe UI"/>
                 <a:ea typeface="Microsoft YaHei"/>
               </a:rPr>
-              <a:t>【中期考核自评与工作定位】  </a:t>
-            </a:r>
-            <a:r>
-              <a:rPr sz="980">
+              <a:t>【中期考核自评与工作定位】</a:t>
+            </a:r>
+          </a:p>
+          <a:p>
+            <a:pPr>
+              <a:lnSpc>
+                <a:spcPct val="118000"/>
+              </a:lnSpc>
+              <a:spcBef>
+                <a:spcPts val="300"/>
+              </a:spcBef>
+            </a:pPr>
+            <a:r>
+              <a:rPr sz="950">
                 <a:solidFill>
                   <a:srgbClr val="334155"/>
                 </a:solidFill>
@@ -7070,21 +6470,31 @@
           <a:p>
             <a:pPr>
               <a:lnSpc>
-                <a:spcPct val="122000"/>
-              </a:lnSpc>
-            </a:pPr>
-            <a:r>
-              <a:rPr sz="1100" b="1">
+                <a:spcPct val="115000"/>
+              </a:lnSpc>
+            </a:pPr>
+            <a:r>
+              <a:rPr sz="1080" b="1">
                 <a:solidFill>
                   <a:srgbClr val="1E3A8A"/>
                 </a:solidFill>
                 <a:latin typeface="Segoe UI"/>
                 <a:ea typeface="Microsoft YaHei"/>
               </a:rPr>
-              <a:t>【核心科学设问 (Core Research Question)】  </a:t>
-            </a:r>
-            <a:r>
-              <a:rPr sz="980">
+              <a:t>【核心科学设问 (Core Research Question)】</a:t>
+            </a:r>
+          </a:p>
+          <a:p>
+            <a:pPr>
+              <a:lnSpc>
+                <a:spcPct val="118000"/>
+              </a:lnSpc>
+              <a:spcBef>
+                <a:spcPts val="300"/>
+              </a:spcBef>
+            </a:pPr>
+            <a:r>
+              <a:rPr sz="950">
                 <a:solidFill>
                   <a:srgbClr val="334155"/>
                 </a:solidFill>
@@ -7873,7 +7283,7 @@
         <p:spPr>
           <a:xfrm>
             <a:off x="756000" y="1116000"/>
-            <a:ext cx="5032800" cy="216000"/>
+            <a:ext cx="5032800" cy="198000"/>
           </a:xfrm>
           <a:prstGeom prst="rect">
             <a:avLst/>
@@ -7908,8 +7318,8 @@
         </p:nvSpPr>
         <p:spPr>
           <a:xfrm>
-            <a:off x="756000" y="1386000"/>
-            <a:ext cx="5032800" cy="306000"/>
+            <a:off x="756000" y="1367999"/>
+            <a:ext cx="5032800" cy="396000"/>
           </a:xfrm>
           <a:prstGeom prst="rect">
             <a:avLst/>
@@ -7918,29 +7328,38 @@
           <a:effectLst/>
         </p:spPr>
         <p:txBody>
-          <a:bodyPr wrap="square">
+          <a:bodyPr wrap="square" lIns="0" rIns="0" tIns="0" bIns="0">
             <a:spAutoFit/>
           </a:bodyPr>
           <a:lstStyle/>
           <a:p>
             <a:pPr>
               <a:lnSpc>
-                <a:spcPct val="122000"/>
-              </a:lnSpc>
-            </a:pPr>
-            <a:r>
-              <a:rPr sz="1150" b="1">
+                <a:spcPct val="115000"/>
+              </a:lnSpc>
+            </a:pPr>
+            <a:r>
+              <a:rPr sz="1120" b="1">
                 <a:solidFill>
                   <a:srgbClr val="1E293B"/>
                 </a:solidFill>
                 <a:latin typeface="Segoe UI"/>
                 <a:ea typeface="Microsoft YaHei"/>
               </a:rPr>
-              <a:t>• 第一阶段：微观传播层（负二项分支过程）
-</a:t>
-            </a:r>
-            <a:r>
-              <a:rPr sz="1019">
+              <a:t>• 第一阶段：微观传播层（负二项分支过程）</a:t>
+            </a:r>
+          </a:p>
+          <a:p>
+            <a:pPr>
+              <a:lnSpc>
+                <a:spcPct val="115000"/>
+              </a:lnSpc>
+              <a:spcBef>
+                <a:spcPts val="200"/>
+              </a:spcBef>
+            </a:pPr>
+            <a:r>
+              <a:rPr sz="960">
                 <a:solidFill>
                   <a:srgbClr val="334155"/>
                 </a:solidFill>
@@ -7960,8 +7379,8 @@
         </p:nvSpPr>
         <p:spPr>
           <a:xfrm>
-            <a:off x="756000" y="1728000"/>
-            <a:ext cx="5032800" cy="413999"/>
+            <a:off x="756000" y="1800000"/>
+            <a:ext cx="5032800" cy="378000"/>
           </a:xfrm>
           <a:prstGeom prst="roundRect">
             <a:avLst>
@@ -7995,15 +7414,15 @@
           <p:nvPr/>
         </p:nvPicPr>
         <p:blipFill>
-          <a:blip r:embed="rId5"/>
+          <a:blip r:embed="rId10"/>
           <a:stretch>
             <a:fillRect/>
           </a:stretch>
         </p:blipFill>
         <p:spPr>
           <a:xfrm>
-            <a:off x="2008466" y="1771200"/>
-            <a:ext cx="2527867" cy="327599"/>
+            <a:off x="2051802" y="1843200"/>
+            <a:ext cx="2441195" cy="291600"/>
           </a:xfrm>
           <a:prstGeom prst="rect">
             <a:avLst/>
@@ -8019,8 +7438,8 @@
         </p:nvSpPr>
         <p:spPr>
           <a:xfrm>
-            <a:off x="756000" y="2196000"/>
-            <a:ext cx="5032800" cy="413999"/>
+            <a:off x="756000" y="2232000"/>
+            <a:ext cx="5032800" cy="378000"/>
           </a:xfrm>
           <a:prstGeom prst="roundRect">
             <a:avLst>
@@ -8054,15 +7473,15 @@
           <p:nvPr/>
         </p:nvPicPr>
         <p:blipFill>
-          <a:blip r:embed="rId6"/>
+          <a:blip r:embed="rId11"/>
           <a:stretch>
             <a:fillRect/>
           </a:stretch>
         </p:blipFill>
         <p:spPr>
           <a:xfrm>
-            <a:off x="2301415" y="2239200"/>
-            <a:ext cx="1941969" cy="327599"/>
+            <a:off x="2335768" y="2275200"/>
+            <a:ext cx="1873262" cy="291600"/>
           </a:xfrm>
           <a:prstGeom prst="rect">
             <a:avLst/>
@@ -8079,7 +7498,7 @@
         <p:spPr>
           <a:xfrm>
             <a:off x="756000" y="2682000"/>
-            <a:ext cx="5032800" cy="306000"/>
+            <a:ext cx="5032800" cy="396000"/>
           </a:xfrm>
           <a:prstGeom prst="rect">
             <a:avLst/>
@@ -8088,29 +7507,38 @@
           <a:effectLst/>
         </p:spPr>
         <p:txBody>
-          <a:bodyPr wrap="square">
+          <a:bodyPr wrap="square" lIns="0" rIns="0" tIns="0" bIns="0">
             <a:spAutoFit/>
           </a:bodyPr>
           <a:lstStyle/>
           <a:p>
             <a:pPr>
               <a:lnSpc>
-                <a:spcPct val="122000"/>
-              </a:lnSpc>
-            </a:pPr>
-            <a:r>
-              <a:rPr sz="1150" b="1">
+                <a:spcPct val="115000"/>
+              </a:lnSpc>
+            </a:pPr>
+            <a:r>
+              <a:rPr sz="1120" b="1">
                 <a:solidFill>
                   <a:srgbClr val="1E293B"/>
                 </a:solidFill>
                 <a:latin typeface="Segoe UI"/>
                 <a:ea typeface="Microsoft YaHei"/>
               </a:rPr>
-              <a:t>• 第二阶段：宏观观测层（条件二项抽稀）
-</a:t>
-            </a:r>
-            <a:r>
-              <a:rPr sz="1019">
+              <a:t>• 第二阶段：宏观观测层（条件二项抽稀）</a:t>
+            </a:r>
+          </a:p>
+          <a:p>
+            <a:pPr>
+              <a:lnSpc>
+                <a:spcPct val="115000"/>
+              </a:lnSpc>
+              <a:spcBef>
+                <a:spcPts val="200"/>
+              </a:spcBef>
+            </a:pPr>
+            <a:r>
+              <a:rPr sz="960">
                 <a:solidFill>
                   <a:srgbClr val="334155"/>
                 </a:solidFill>
@@ -8130,8 +7558,8 @@
         </p:nvSpPr>
         <p:spPr>
           <a:xfrm>
-            <a:off x="756000" y="3024000"/>
-            <a:ext cx="5032800" cy="413999"/>
+            <a:off x="756000" y="3114000"/>
+            <a:ext cx="5032800" cy="378000"/>
           </a:xfrm>
           <a:prstGeom prst="roundRect">
             <a:avLst>
@@ -8165,15 +7593,15 @@
           <p:nvPr/>
         </p:nvPicPr>
         <p:blipFill>
-          <a:blip r:embed="rId7"/>
+          <a:blip r:embed="rId12"/>
           <a:stretch>
             <a:fillRect/>
           </a:stretch>
         </p:blipFill>
         <p:spPr>
           <a:xfrm>
-            <a:off x="1935229" y="3067200"/>
-            <a:ext cx="2674341" cy="327599"/>
+            <a:off x="1980810" y="3157200"/>
+            <a:ext cx="2583179" cy="291600"/>
           </a:xfrm>
           <a:prstGeom prst="rect">
             <a:avLst/>
@@ -8189,7 +7617,7 @@
         </p:nvSpPr>
         <p:spPr>
           <a:xfrm>
-            <a:off x="756000" y="3510000"/>
+            <a:off x="756000" y="3564000"/>
             <a:ext cx="5032800" cy="846000"/>
           </a:xfrm>
           <a:prstGeom prst="roundRect">
@@ -8223,7 +7651,7 @@
         </p:nvSpPr>
         <p:spPr>
           <a:xfrm>
-            <a:off x="900000" y="3582000"/>
+            <a:off x="900000" y="3636000"/>
             <a:ext cx="4744800" cy="702000"/>
           </a:xfrm>
           <a:prstGeom prst="rect">
@@ -8240,21 +7668,31 @@
           <a:p>
             <a:pPr>
               <a:lnSpc>
-                <a:spcPct val="122000"/>
-              </a:lnSpc>
-            </a:pPr>
-            <a:r>
-              <a:rPr sz="1100" b="1">
+                <a:spcPct val="115000"/>
+              </a:lnSpc>
+            </a:pPr>
+            <a:r>
+              <a:rPr sz="1080" b="1">
                 <a:solidFill>
                   <a:srgbClr val="1E3A8A"/>
                 </a:solidFill>
                 <a:latin typeface="Segoe UI"/>
                 <a:ea typeface="Microsoft YaHei"/>
               </a:rPr>
-              <a:t>【成功概率 p 的统计物理顿悟】  </a:t>
-            </a:r>
-            <a:r>
-              <a:rPr sz="980">
+              <a:t>【成功概率 p 的统计物理顿悟】</a:t>
+            </a:r>
+          </a:p>
+          <a:p>
+            <a:pPr>
+              <a:lnSpc>
+                <a:spcPct val="118000"/>
+              </a:lnSpc>
+              <a:spcBef>
+                <a:spcPts val="300"/>
+              </a:spcBef>
+            </a:pPr>
+            <a:r>
+              <a:rPr sz="950">
                 <a:solidFill>
                   <a:srgbClr val="334155"/>
                 </a:solidFill>
@@ -8274,8 +7712,8 @@
         </p:nvSpPr>
         <p:spPr>
           <a:xfrm>
-            <a:off x="756000" y="4428000"/>
-            <a:ext cx="5032800" cy="1800000"/>
+            <a:off x="756000" y="4482000"/>
+            <a:ext cx="5032800" cy="1745999"/>
           </a:xfrm>
           <a:prstGeom prst="roundRect">
             <a:avLst>
@@ -8308,8 +7746,8 @@
         </p:nvSpPr>
         <p:spPr>
           <a:xfrm>
-            <a:off x="864000" y="4500000"/>
-            <a:ext cx="4816800" cy="1655999"/>
+            <a:off x="864000" y="4554000"/>
+            <a:ext cx="4816800" cy="1602000"/>
           </a:xfrm>
           <a:prstGeom prst="rect">
             <a:avLst/>
@@ -8329,7 +7767,7 @@
               </a:lnSpc>
             </a:pPr>
             <a:r>
-              <a:rPr sz="1150" b="1">
+              <a:rPr sz="1120" b="1">
                 <a:solidFill>
                   <a:srgbClr val="1E3A8A"/>
                 </a:solidFill>
@@ -8342,14 +7780,14 @@
           <a:p>
             <a:pPr>
               <a:lnSpc>
-                <a:spcPct val="120000"/>
+                <a:spcPct val="118000"/>
               </a:lnSpc>
               <a:spcBef>
                 <a:spcPts val="400"/>
               </a:spcBef>
             </a:pPr>
             <a:r>
-              <a:rPr sz="1019" b="1">
+              <a:rPr sz="1000" b="1">
                 <a:solidFill>
                   <a:srgbClr val="1E293B"/>
                 </a:solidFill>
@@ -8360,7 +7798,7 @@
 </a:t>
             </a:r>
             <a:r>
-              <a:rPr sz="980">
+              <a:rPr sz="950">
                 <a:solidFill>
                   <a:srgbClr val="334155"/>
                 </a:solidFill>
@@ -8373,14 +7811,14 @@
           <a:p>
             <a:pPr>
               <a:lnSpc>
-                <a:spcPct val="120000"/>
+                <a:spcPct val="118000"/>
               </a:lnSpc>
               <a:spcBef>
                 <a:spcPts val="400"/>
               </a:spcBef>
             </a:pPr>
             <a:r>
-              <a:rPr sz="1019" b="1">
+              <a:rPr sz="1000" b="1">
                 <a:solidFill>
                   <a:srgbClr val="1E293B"/>
                 </a:solidFill>
@@ -8391,27 +7829,27 @@
 </a:t>
             </a:r>
             <a:r>
-              <a:rPr sz="980">
+              <a:rPr sz="950">
                 <a:solidFill>
                   <a:srgbClr val="334155"/>
                 </a:solidFill>
                 <a:latin typeface="Segoe UI"/>
                 <a:ea typeface="Microsoft YaHei"/>
               </a:rPr>
-              <a:t>  报告率 ρ 仅缩放观测期望均值，但不改变负二项分布的族系属性。</a:t>
+              <a:t>  报告率 ρ 仅缩放观测期望均值，但不改变负二项分布族系属性。</a:t>
             </a:r>
           </a:p>
           <a:p>
             <a:pPr>
               <a:lnSpc>
-                <a:spcPct val="120000"/>
+                <a:spcPct val="118000"/>
               </a:lnSpc>
               <a:spcBef>
                 <a:spcPts val="400"/>
               </a:spcBef>
             </a:pPr>
             <a:r>
-              <a:rPr sz="1019" b="1">
+              <a:rPr sz="1000" b="1">
                 <a:solidFill>
                   <a:srgbClr val="1E293B"/>
                 </a:solidFill>
@@ -8422,7 +7860,7 @@
 </a:t>
             </a:r>
             <a:r>
-              <a:rPr sz="980">
+              <a:rPr sz="950">
                 <a:solidFill>
                   <a:srgbClr val="334155"/>
                 </a:solidFill>
@@ -8477,7 +7915,7 @@
         <p:spPr>
           <a:xfrm>
             <a:off x="6400800" y="1116000"/>
-            <a:ext cx="5032800" cy="216000"/>
+            <a:ext cx="5032800" cy="198000"/>
           </a:xfrm>
           <a:prstGeom prst="rect">
             <a:avLst/>
@@ -8512,8 +7950,8 @@
         </p:nvSpPr>
         <p:spPr>
           <a:xfrm>
-            <a:off x="6400800" y="1386000"/>
-            <a:ext cx="5032800" cy="306000"/>
+            <a:off x="6400800" y="1367999"/>
+            <a:ext cx="5032800" cy="396000"/>
           </a:xfrm>
           <a:prstGeom prst="rect">
             <a:avLst/>
@@ -8522,29 +7960,38 @@
           <a:effectLst/>
         </p:spPr>
         <p:txBody>
-          <a:bodyPr wrap="square">
+          <a:bodyPr wrap="square" lIns="0" rIns="0" tIns="0" bIns="0">
             <a:spAutoFit/>
           </a:bodyPr>
           <a:lstStyle/>
           <a:p>
             <a:pPr>
               <a:lnSpc>
-                <a:spcPct val="122000"/>
-              </a:lnSpc>
-            </a:pPr>
-            <a:r>
-              <a:rPr sz="1150" b="1">
+                <a:spcPct val="115000"/>
+              </a:lnSpc>
+            </a:pPr>
+            <a:r>
+              <a:rPr sz="1120" b="1">
                 <a:solidFill>
                   <a:srgbClr val="1E293B"/>
                 </a:solidFill>
                 <a:latin typeface="Segoe UI"/>
                 <a:ea typeface="Microsoft YaHei"/>
               </a:rPr>
-              <a:t>• 严格保族性定理（PGF 复合闭合）
-</a:t>
-            </a:r>
-            <a:r>
-              <a:rPr sz="1019">
+              <a:t>• 严格保族性定理（PGF 复合闭合）</a:t>
+            </a:r>
+          </a:p>
+          <a:p>
+            <a:pPr>
+              <a:lnSpc>
+                <a:spcPct val="115000"/>
+              </a:lnSpc>
+              <a:spcBef>
+                <a:spcPts val="200"/>
+              </a:spcBef>
+            </a:pPr>
+            <a:r>
+              <a:rPr sz="960">
                 <a:solidFill>
                   <a:srgbClr val="334155"/>
                 </a:solidFill>
@@ -8564,8 +8011,8 @@
         </p:nvSpPr>
         <p:spPr>
           <a:xfrm>
-            <a:off x="6400800" y="1746000"/>
-            <a:ext cx="5032800" cy="432000"/>
+            <a:off x="6400800" y="1800000"/>
+            <a:ext cx="5032800" cy="413999"/>
           </a:xfrm>
           <a:prstGeom prst="roundRect">
             <a:avLst>
@@ -8599,15 +8046,15 @@
           <p:nvPr/>
         </p:nvPicPr>
         <p:blipFill>
-          <a:blip r:embed="rId8"/>
+          <a:blip r:embed="rId13"/>
           <a:stretch>
             <a:fillRect/>
           </a:stretch>
         </p:blipFill>
         <p:spPr>
           <a:xfrm>
-            <a:off x="7931907" y="1789200"/>
-            <a:ext cx="1970584" cy="345600"/>
+            <a:off x="7905244" y="1843200"/>
+            <a:ext cx="2023910" cy="327599"/>
           </a:xfrm>
           <a:prstGeom prst="rect">
             <a:avLst/>
@@ -8623,8 +8070,8 @@
         </p:nvSpPr>
         <p:spPr>
           <a:xfrm>
-            <a:off x="6400800" y="2250000"/>
-            <a:ext cx="5032800" cy="306000"/>
+            <a:off x="6400800" y="2304000"/>
+            <a:ext cx="5032800" cy="396000"/>
           </a:xfrm>
           <a:prstGeom prst="rect">
             <a:avLst/>
@@ -8633,29 +8080,38 @@
           <a:effectLst/>
         </p:spPr>
         <p:txBody>
-          <a:bodyPr wrap="square">
+          <a:bodyPr wrap="square" lIns="0" rIns="0" tIns="0" bIns="0">
             <a:spAutoFit/>
           </a:bodyPr>
           <a:lstStyle/>
           <a:p>
             <a:pPr>
               <a:lnSpc>
-                <a:spcPct val="122000"/>
-              </a:lnSpc>
-            </a:pPr>
-            <a:r>
-              <a:rPr sz="1150" b="1">
+                <a:spcPct val="115000"/>
+              </a:lnSpc>
+            </a:pPr>
+            <a:r>
+              <a:rPr sz="1120" b="1">
                 <a:solidFill>
                   <a:srgbClr val="1E293B"/>
                 </a:solidFill>
                 <a:latin typeface="Segoe UI"/>
                 <a:ea typeface="Microsoft YaHei"/>
               </a:rPr>
-              <a:t>• 统计参数内涵与二阶矩结构
-</a:t>
-            </a:r>
-            <a:r>
-              <a:rPr sz="1019">
+              <a:t>• 统计参数内涵与二阶矩结构</a:t>
+            </a:r>
+          </a:p>
+          <a:p>
+            <a:pPr>
+              <a:lnSpc>
+                <a:spcPct val="115000"/>
+              </a:lnSpc>
+              <a:spcBef>
+                <a:spcPts val="200"/>
+              </a:spcBef>
+            </a:pPr>
+            <a:r>
+              <a:rPr sz="960">
                 <a:solidFill>
                   <a:srgbClr val="334155"/>
                 </a:solidFill>
@@ -8675,8 +8131,8 @@
         </p:nvSpPr>
         <p:spPr>
           <a:xfrm>
-            <a:off x="6400800" y="2592000"/>
-            <a:ext cx="5032800" cy="432000"/>
+            <a:off x="6400800" y="2736000"/>
+            <a:ext cx="5032800" cy="413999"/>
           </a:xfrm>
           <a:prstGeom prst="roundRect">
             <a:avLst>
@@ -8710,15 +8166,15 @@
           <p:nvPr/>
         </p:nvPicPr>
         <p:blipFill>
-          <a:blip r:embed="rId9"/>
+          <a:blip r:embed="rId14"/>
           <a:stretch>
             <a:fillRect/>
           </a:stretch>
         </p:blipFill>
         <p:spPr>
           <a:xfrm>
-            <a:off x="7931907" y="2635200"/>
-            <a:ext cx="1970584" cy="345600"/>
+            <a:off x="7905244" y="2779200"/>
+            <a:ext cx="2023910" cy="327599"/>
           </a:xfrm>
           <a:prstGeom prst="rect">
             <a:avLst/>
@@ -8734,8 +8190,8 @@
         </p:nvSpPr>
         <p:spPr>
           <a:xfrm>
-            <a:off x="6400800" y="3114000"/>
-            <a:ext cx="5032800" cy="3114000"/>
+            <a:off x="6400800" y="3240000"/>
+            <a:ext cx="5032800" cy="2988000"/>
           </a:xfrm>
           <a:prstGeom prst="roundRect">
             <a:avLst>
@@ -8768,8 +8224,8 @@
         </p:nvSpPr>
         <p:spPr>
           <a:xfrm>
-            <a:off x="6508800" y="3204000"/>
-            <a:ext cx="4816800" cy="2951999"/>
+            <a:off x="6508800" y="3312000"/>
+            <a:ext cx="4816800" cy="2844000"/>
           </a:xfrm>
           <a:prstGeom prst="rect">
             <a:avLst/>
@@ -8789,7 +8245,7 @@
               </a:lnSpc>
             </a:pPr>
             <a:r>
-              <a:rPr sz="1150" b="1">
+              <a:rPr sz="1120" b="1">
                 <a:solidFill>
                   <a:srgbClr val="1E3A8A"/>
                 </a:solidFill>
@@ -8802,14 +8258,14 @@
           <a:p>
             <a:pPr>
               <a:lnSpc>
-                <a:spcPct val="122000"/>
+                <a:spcPct val="118000"/>
               </a:lnSpc>
               <a:spcBef>
-                <a:spcPts val="500"/>
+                <a:spcPts val="400"/>
               </a:spcBef>
             </a:pPr>
             <a:r>
-              <a:rPr sz="1019" b="1">
+              <a:rPr sz="1000" b="1">
                 <a:solidFill>
                   <a:srgbClr val="1E293B"/>
                 </a:solidFill>
@@ -8820,7 +8276,7 @@
 </a:t>
             </a:r>
             <a:r>
-              <a:rPr sz="980">
+              <a:rPr sz="950">
                 <a:solidFill>
                   <a:srgbClr val="334155"/>
                 </a:solidFill>
@@ -8833,14 +8289,14 @@
           <a:p>
             <a:pPr>
               <a:lnSpc>
-                <a:spcPct val="122000"/>
+                <a:spcPct val="118000"/>
               </a:lnSpc>
               <a:spcBef>
-                <a:spcPts val="500"/>
+                <a:spcPts val="400"/>
               </a:spcBef>
             </a:pPr>
             <a:r>
-              <a:rPr sz="1019" b="1">
+              <a:rPr sz="1000" b="1">
                 <a:solidFill>
                   <a:srgbClr val="1E293B"/>
                 </a:solidFill>
@@ -8851,7 +8307,7 @@
 </a:t>
             </a:r>
             <a:r>
-              <a:rPr sz="980">
+              <a:rPr sz="950">
                 <a:solidFill>
                   <a:srgbClr val="334155"/>
                 </a:solidFill>
@@ -8864,14 +8320,14 @@
           <a:p>
             <a:pPr>
               <a:lnSpc>
-                <a:spcPct val="122000"/>
+                <a:spcPct val="118000"/>
               </a:lnSpc>
               <a:spcBef>
-                <a:spcPts val="500"/>
+                <a:spcPts val="400"/>
               </a:spcBef>
             </a:pPr>
             <a:r>
-              <a:rPr sz="1019" b="1">
+              <a:rPr sz="1000" b="1">
                 <a:solidFill>
                   <a:srgbClr val="1E293B"/>
                 </a:solidFill>
@@ -8882,7 +8338,7 @@
 </a:t>
             </a:r>
             <a:r>
-              <a:rPr sz="980">
+              <a:rPr sz="950">
                 <a:solidFill>
                   <a:srgbClr val="334155"/>
                 </a:solidFill>
@@ -8895,14 +8351,14 @@
           <a:p>
             <a:pPr>
               <a:lnSpc>
-                <a:spcPct val="122000"/>
+                <a:spcPct val="118000"/>
               </a:lnSpc>
               <a:spcBef>
-                <a:spcPts val="500"/>
+                <a:spcPts val="400"/>
               </a:spcBef>
             </a:pPr>
             <a:r>
-              <a:rPr sz="1019" b="1">
+              <a:rPr sz="1000" b="1">
                 <a:solidFill>
                   <a:srgbClr val="1E293B"/>
                 </a:solidFill>
@@ -8913,7 +8369,7 @@
 </a:t>
             </a:r>
             <a:r>
-              <a:rPr sz="980">
+              <a:rPr sz="950">
                 <a:solidFill>
                   <a:srgbClr val="334155"/>
                 </a:solidFill>
@@ -9139,7 +8595,7 @@
         <p:spPr>
           <a:xfrm>
             <a:off x="756000" y="1116000"/>
-            <a:ext cx="5032800" cy="216000"/>
+            <a:ext cx="5032800" cy="198000"/>
           </a:xfrm>
           <a:prstGeom prst="rect">
             <a:avLst/>
@@ -9175,7 +8631,7 @@
         <p:spPr>
           <a:xfrm>
             <a:off x="756000" y="1367999"/>
-            <a:ext cx="5032800" cy="251999"/>
+            <a:ext cx="5032800" cy="378000"/>
           </a:xfrm>
           <a:prstGeom prst="rect">
             <a:avLst/>
@@ -9184,7 +8640,7 @@
           <a:effectLst/>
         </p:spPr>
         <p:txBody>
-          <a:bodyPr wrap="square">
+          <a:bodyPr wrap="square" lIns="0" rIns="0" tIns="0" bIns="0">
             <a:spAutoFit/>
           </a:bodyPr>
           <a:lstStyle/>
@@ -9202,11 +8658,20 @@
                 <a:latin typeface="Segoe UI"/>
                 <a:ea typeface="Microsoft YaHei"/>
               </a:rPr>
-              <a:t>• 矩估计量定义与双层全期望无偏性（塔式法则）：
-</a:t>
-            </a:r>
-            <a:r>
-              <a:rPr sz="980">
+              <a:t>• 矩估计量定义与双层全期望无偏性（塔式法则）：</a:t>
+            </a:r>
+          </a:p>
+          <a:p>
+            <a:pPr>
+              <a:lnSpc>
+                <a:spcPct val="115000"/>
+              </a:lnSpc>
+              <a:spcBef>
+                <a:spcPts val="200"/>
+              </a:spcBef>
+            </a:pPr>
+            <a:r>
+              <a:rPr sz="950">
                 <a:solidFill>
                   <a:srgbClr val="334155"/>
                 </a:solidFill>
@@ -9226,8 +8691,8 @@
         </p:nvSpPr>
         <p:spPr>
           <a:xfrm>
-            <a:off x="756000" y="1691999"/>
-            <a:ext cx="5032800" cy="413999"/>
+            <a:off x="756000" y="1764000"/>
+            <a:ext cx="5032800" cy="378000"/>
           </a:xfrm>
           <a:prstGeom prst="roundRect">
             <a:avLst>
@@ -9261,15 +8726,15 @@
           <p:nvPr/>
         </p:nvPicPr>
         <p:blipFill>
-          <a:blip r:embed="rId6"/>
+          <a:blip r:embed="rId11"/>
           <a:stretch>
             <a:fillRect/>
           </a:stretch>
         </p:blipFill>
         <p:spPr>
           <a:xfrm>
-            <a:off x="2374652" y="1735199"/>
-            <a:ext cx="1795494" cy="327599"/>
+            <a:off x="2406760" y="1807200"/>
+            <a:ext cx="1731279" cy="291600"/>
           </a:xfrm>
           <a:prstGeom prst="rect">
             <a:avLst/>
@@ -9285,8 +8750,8 @@
         </p:nvSpPr>
         <p:spPr>
           <a:xfrm>
-            <a:off x="756000" y="2160000"/>
-            <a:ext cx="5032800" cy="251999"/>
+            <a:off x="756000" y="2196000"/>
+            <a:ext cx="5032800" cy="378000"/>
           </a:xfrm>
           <a:prstGeom prst="rect">
             <a:avLst/>
@@ -9295,7 +8760,7 @@
           <a:effectLst/>
         </p:spPr>
         <p:txBody>
-          <a:bodyPr wrap="square">
+          <a:bodyPr wrap="square" lIns="0" rIns="0" tIns="0" bIns="0">
             <a:spAutoFit/>
           </a:bodyPr>
           <a:lstStyle/>
@@ -9313,18 +8778,27 @@
                 <a:latin typeface="Segoe UI"/>
                 <a:ea typeface="Microsoft YaHei"/>
               </a:rPr>
-              <a:t>• 条件方差展开与无界 O(1/m) 衰减：
-</a:t>
-            </a:r>
-            <a:r>
-              <a:rPr sz="980">
+              <a:t>• 条件方差展开与无界 O(1/m) 衰减：</a:t>
+            </a:r>
+          </a:p>
+          <a:p>
+            <a:pPr>
+              <a:lnSpc>
+                <a:spcPct val="115000"/>
+              </a:lnSpc>
+              <a:spcBef>
+                <a:spcPts val="200"/>
+              </a:spcBef>
+            </a:pPr>
+            <a:r>
+              <a:rPr sz="950">
                 <a:solidFill>
                   <a:srgbClr val="334155"/>
                 </a:solidFill>
                 <a:latin typeface="Segoe UI"/>
                 <a:ea typeface="Microsoft YaHei"/>
               </a:rPr>
-              <a:t>微观抽样与超传播两项方差均与期望规模 m 成反比，样本量趋于无穷时方差趋于零：</a:t>
+              <a:t>微观抽样与超传播两项方差均与期望规模 m 成反比，样本量无穷时方差趋于零：</a:t>
             </a:r>
           </a:p>
         </p:txBody>
@@ -9337,8 +8811,8 @@
         </p:nvSpPr>
         <p:spPr>
           <a:xfrm>
-            <a:off x="756000" y="2484000"/>
-            <a:ext cx="5032800" cy="413999"/>
+            <a:off x="756000" y="2592000"/>
+            <a:ext cx="5032800" cy="378000"/>
           </a:xfrm>
           <a:prstGeom prst="roundRect">
             <a:avLst>
@@ -9372,15 +8846,15 @@
           <p:nvPr/>
         </p:nvPicPr>
         <p:blipFill>
-          <a:blip r:embed="rId7"/>
+          <a:blip r:embed="rId12"/>
           <a:stretch>
             <a:fillRect/>
           </a:stretch>
         </p:blipFill>
         <p:spPr>
           <a:xfrm>
-            <a:off x="2250886" y="2527200"/>
-            <a:ext cx="2043026" cy="327599"/>
+            <a:off x="2229662" y="2635200"/>
+            <a:ext cx="2085474" cy="291600"/>
           </a:xfrm>
           <a:prstGeom prst="rect">
             <a:avLst/>
@@ -9396,8 +8870,8 @@
         </p:nvSpPr>
         <p:spPr>
           <a:xfrm>
-            <a:off x="756000" y="2952000"/>
-            <a:ext cx="5032800" cy="251999"/>
+            <a:off x="756000" y="3024000"/>
+            <a:ext cx="5032800" cy="378000"/>
           </a:xfrm>
           <a:prstGeom prst="rect">
             <a:avLst/>
@@ -9406,7 +8880,7 @@
           <a:effectLst/>
         </p:spPr>
         <p:txBody>
-          <a:bodyPr wrap="square">
+          <a:bodyPr wrap="square" lIns="0" rIns="0" tIns="0" bIns="0">
             <a:spAutoFit/>
           </a:bodyPr>
           <a:lstStyle/>
@@ -9424,11 +8898,20 @@
                 <a:latin typeface="Segoe UI"/>
                 <a:ea typeface="Microsoft YaHei"/>
               </a:rPr>
-              <a:t>• Fisher 信息量与 Cramér–Rao 下界确立（UMVUE）：
-</a:t>
-            </a:r>
-            <a:r>
-              <a:rPr sz="980">
+              <a:t>• Fisher 信息量与 Cramér–Rao 下界确立（UMVUE）：</a:t>
+            </a:r>
+          </a:p>
+          <a:p>
+            <a:pPr>
+              <a:lnSpc>
+                <a:spcPct val="115000"/>
+              </a:lnSpc>
+              <a:spcBef>
+                <a:spcPts val="200"/>
+              </a:spcBef>
+            </a:pPr>
+            <a:r>
+              <a:rPr sz="950">
                 <a:solidFill>
                   <a:srgbClr val="334155"/>
                 </a:solidFill>
@@ -9448,8 +8931,8 @@
         </p:nvSpPr>
         <p:spPr>
           <a:xfrm>
-            <a:off x="756000" y="3276000"/>
-            <a:ext cx="5032800" cy="413999"/>
+            <a:off x="756000" y="3420000"/>
+            <a:ext cx="5032800" cy="378000"/>
           </a:xfrm>
           <a:prstGeom prst="roundRect">
             <a:avLst>
@@ -9483,15 +8966,15 @@
           <p:nvPr/>
         </p:nvPicPr>
         <p:blipFill>
-          <a:blip r:embed="rId8"/>
+          <a:blip r:embed="rId13"/>
           <a:stretch>
             <a:fillRect/>
           </a:stretch>
         </p:blipFill>
         <p:spPr>
           <a:xfrm>
-            <a:off x="1996997" y="3319200"/>
-            <a:ext cx="2550804" cy="327599"/>
+            <a:off x="1969360" y="3463200"/>
+            <a:ext cx="2606079" cy="291600"/>
           </a:xfrm>
           <a:prstGeom prst="rect">
             <a:avLst/>
@@ -9507,8 +8990,8 @@
         </p:nvSpPr>
         <p:spPr>
           <a:xfrm>
-            <a:off x="756000" y="3780000"/>
-            <a:ext cx="5032800" cy="2448000"/>
+            <a:off x="756000" y="3870000"/>
+            <a:ext cx="5032800" cy="2376000"/>
           </a:xfrm>
           <a:prstGeom prst="roundRect">
             <a:avLst>
@@ -9541,8 +9024,8 @@
         </p:nvSpPr>
         <p:spPr>
           <a:xfrm>
-            <a:off x="864000" y="3852000"/>
-            <a:ext cx="4816800" cy="2304000"/>
+            <a:off x="864000" y="3942000"/>
+            <a:ext cx="4816800" cy="2232000"/>
           </a:xfrm>
           <a:prstGeom prst="rect">
             <a:avLst/>
@@ -9562,7 +9045,7 @@
               </a:lnSpc>
             </a:pPr>
             <a:r>
-              <a:rPr sz="1150" b="1">
+              <a:rPr sz="1120" b="1">
                 <a:solidFill>
                   <a:srgbClr val="1E3A8A"/>
                 </a:solidFill>
@@ -9575,14 +9058,14 @@
           <a:p>
             <a:pPr>
               <a:lnSpc>
-                <a:spcPct val="122000"/>
+                <a:spcPct val="118000"/>
               </a:lnSpc>
               <a:spcBef>
-                <a:spcPts val="500"/>
+                <a:spcPts val="400"/>
               </a:spcBef>
             </a:pPr>
             <a:r>
-              <a:rPr sz="1019" b="1">
+              <a:rPr sz="1000" b="1">
                 <a:solidFill>
                   <a:srgbClr val="1E293B"/>
                 </a:solidFill>
@@ -9593,7 +9076,7 @@
 </a:t>
             </a:r>
             <a:r>
-              <a:rPr sz="980">
+              <a:rPr sz="950">
                 <a:solidFill>
                   <a:srgbClr val="334155"/>
                 </a:solidFill>
@@ -9606,14 +9089,14 @@
           <a:p>
             <a:pPr>
               <a:lnSpc>
-                <a:spcPct val="122000"/>
+                <a:spcPct val="118000"/>
               </a:lnSpc>
               <a:spcBef>
-                <a:spcPts val="500"/>
+                <a:spcPts val="400"/>
               </a:spcBef>
             </a:pPr>
             <a:r>
-              <a:rPr sz="1019" b="1">
+              <a:rPr sz="1000" b="1">
                 <a:solidFill>
                   <a:srgbClr val="1E293B"/>
                 </a:solidFill>
@@ -9624,7 +9107,7 @@
 </a:t>
             </a:r>
             <a:r>
-              <a:rPr sz="980">
+              <a:rPr sz="950">
                 <a:solidFill>
                   <a:srgbClr val="334155"/>
                 </a:solidFill>
@@ -9637,14 +9120,14 @@
           <a:p>
             <a:pPr>
               <a:lnSpc>
-                <a:spcPct val="122000"/>
+                <a:spcPct val="118000"/>
               </a:lnSpc>
               <a:spcBef>
-                <a:spcPts val="500"/>
+                <a:spcPts val="400"/>
               </a:spcBef>
             </a:pPr>
             <a:r>
-              <a:rPr sz="1019" b="1">
+              <a:rPr sz="1000" b="1">
                 <a:solidFill>
                   <a:srgbClr val="1E293B"/>
                 </a:solidFill>
@@ -9655,7 +9138,7 @@
 </a:t>
             </a:r>
             <a:r>
-              <a:rPr sz="980">
+              <a:rPr sz="950">
                 <a:solidFill>
                   <a:srgbClr val="334155"/>
                 </a:solidFill>
@@ -9710,7 +9193,7 @@
         <p:spPr>
           <a:xfrm>
             <a:off x="6400800" y="1116000"/>
-            <a:ext cx="5032800" cy="216000"/>
+            <a:ext cx="5032800" cy="198000"/>
           </a:xfrm>
           <a:prstGeom prst="rect">
             <a:avLst/>
@@ -9746,7 +9229,7 @@
         <p:spPr>
           <a:xfrm>
             <a:off x="6400800" y="1367999"/>
-            <a:ext cx="5032800" cy="251999"/>
+            <a:ext cx="5032800" cy="378000"/>
           </a:xfrm>
           <a:prstGeom prst="rect">
             <a:avLst/>
@@ -9755,7 +9238,7 @@
           <a:effectLst/>
         </p:spPr>
         <p:txBody>
-          <a:bodyPr wrap="square">
+          <a:bodyPr wrap="square" lIns="0" rIns="0" tIns="0" bIns="0">
             <a:spAutoFit/>
           </a:bodyPr>
           <a:lstStyle/>
@@ -9773,18 +9256,27 @@
                 <a:latin typeface="Segoe UI"/>
                 <a:ea typeface="Microsoft YaHei"/>
               </a:rPr>
-              <a:t>• 跨期基准全方差分解与仿射损失结构（命题 2）：
-</a:t>
-            </a:r>
-            <a:r>
-              <a:rPr sz="980">
+              <a:t>• 跨期基准全方差分解与仿射损失结构（命题 2）：</a:t>
+            </a:r>
+          </a:p>
+          <a:p>
+            <a:pPr>
+              <a:lnSpc>
+                <a:spcPct val="115000"/>
+              </a:lnSpc>
+              <a:spcBef>
+                <a:spcPts val="200"/>
+              </a:spcBef>
+            </a:pPr>
+            <a:r>
+              <a:rPr sz="950">
                 <a:solidFill>
                   <a:srgbClr val="334155"/>
                 </a:solidFill>
                 <a:latin typeface="Segoe UI"/>
                 <a:ea typeface="Microsoft YaHei"/>
               </a:rPr>
-              <a:t>存在宏观不可约环境方差 v_R 时，单期样本再大也无法突破环境底板，呈现仿射形态：</a:t>
+              <a:t>存在宏观不可约环境方差 v_R 时，单期样本再大也无法突破底板，呈现仿射形态：</a:t>
             </a:r>
           </a:p>
         </p:txBody>
@@ -9797,8 +9289,8 @@
         </p:nvSpPr>
         <p:spPr>
           <a:xfrm>
-            <a:off x="6400800" y="1691999"/>
-            <a:ext cx="5032800" cy="413999"/>
+            <a:off x="6400800" y="1764000"/>
+            <a:ext cx="5032800" cy="378000"/>
           </a:xfrm>
           <a:prstGeom prst="roundRect">
             <a:avLst>
@@ -9832,15 +9324,15 @@
           <p:nvPr/>
         </p:nvPicPr>
         <p:blipFill>
-          <a:blip r:embed="rId3"/>
+          <a:blip r:embed="rId14"/>
           <a:stretch>
             <a:fillRect/>
           </a:stretch>
         </p:blipFill>
         <p:spPr>
           <a:xfrm>
-            <a:off x="7826444" y="1735199"/>
-            <a:ext cx="2181511" cy="327599"/>
+            <a:off x="7803471" y="1807200"/>
+            <a:ext cx="2227457" cy="291600"/>
           </a:xfrm>
           <a:prstGeom prst="rect">
             <a:avLst/>
@@ -9856,8 +9348,8 @@
         </p:nvSpPr>
         <p:spPr>
           <a:xfrm>
-            <a:off x="6400800" y="2160000"/>
-            <a:ext cx="5032800" cy="413999"/>
+            <a:off x="6400800" y="2196000"/>
+            <a:ext cx="5032800" cy="378000"/>
           </a:xfrm>
           <a:prstGeom prst="roundRect">
             <a:avLst>
@@ -9891,15 +9383,15 @@
           <p:nvPr/>
         </p:nvPicPr>
         <p:blipFill>
-          <a:blip r:embed="rId4"/>
+          <a:blip r:embed="rId15"/>
           <a:stretch>
             <a:fillRect/>
           </a:stretch>
         </p:blipFill>
         <p:spPr>
           <a:xfrm>
-            <a:off x="7999178" y="2203200"/>
-            <a:ext cx="1836043" cy="327599"/>
+            <a:off x="7980568" y="2239200"/>
+            <a:ext cx="1873262" cy="291600"/>
           </a:xfrm>
           <a:prstGeom prst="rect">
             <a:avLst/>
@@ -9916,7 +9408,7 @@
         <p:spPr>
           <a:xfrm>
             <a:off x="6400800" y="2628000"/>
-            <a:ext cx="5032800" cy="251999"/>
+            <a:ext cx="5032800" cy="378000"/>
           </a:xfrm>
           <a:prstGeom prst="rect">
             <a:avLst/>
@@ -9925,7 +9417,7 @@
           <a:effectLst/>
         </p:spPr>
         <p:txBody>
-          <a:bodyPr wrap="square">
+          <a:bodyPr wrap="square" lIns="0" rIns="0" tIns="0" bIns="0">
             <a:spAutoFit/>
           </a:bodyPr>
           <a:lstStyle/>
@@ -9943,11 +9435,20 @@
                 <a:latin typeface="Segoe UI"/>
                 <a:ea typeface="Microsoft YaHei"/>
               </a:rPr>
-              <a:t>• 命题 3：监测杠杆的理论非对称性定理：
-</a:t>
-            </a:r>
-            <a:r>
-              <a:rPr sz="980">
+              <a:t>• 命题 3：监测杠杆的理论非对称性定理：</a:t>
+            </a:r>
+          </a:p>
+          <a:p>
+            <a:pPr>
+              <a:lnSpc>
+                <a:spcPct val="115000"/>
+              </a:lnSpc>
+              <a:spcBef>
+                <a:spcPts val="200"/>
+              </a:spcBef>
+            </a:pPr>
+            <a:r>
+              <a:rPr sz="950">
                 <a:solidFill>
                   <a:srgbClr val="334155"/>
                 </a:solidFill>
@@ -9967,8 +9468,8 @@
         </p:nvSpPr>
         <p:spPr>
           <a:xfrm>
-            <a:off x="6400800" y="2952000"/>
-            <a:ext cx="5032800" cy="468000"/>
+            <a:off x="6400800" y="3024000"/>
+            <a:ext cx="5032800" cy="413999"/>
           </a:xfrm>
           <a:prstGeom prst="roundRect">
             <a:avLst>
@@ -9995,22 +9496,22 @@
       </p:sp>
       <p:pic>
         <p:nvPicPr>
-          <p:cNvPr id="28" name="Picture 27" descr="s3_levers_asymmetry.png"/>
+          <p:cNvPr id="28" name="Picture 27" descr="image.png"/>
           <p:cNvPicPr>
             <a:picLocks noChangeAspect="1"/>
           </p:cNvPicPr>
           <p:nvPr/>
         </p:nvPicPr>
         <p:blipFill>
-          <a:blip r:embed="rId9"/>
+          <a:blip r:embed="rId16"/>
           <a:stretch>
             <a:fillRect/>
           </a:stretch>
         </p:blipFill>
         <p:spPr>
           <a:xfrm>
-            <a:off x="6508800" y="3068098"/>
-            <a:ext cx="4816800" cy="235802"/>
+            <a:off x="7386403" y="3067200"/>
+            <a:ext cx="3061592" cy="327599"/>
           </a:xfrm>
           <a:prstGeom prst="rect">
             <a:avLst/>
@@ -10027,7 +9528,7 @@
         <p:spPr>
           <a:xfrm>
             <a:off x="6400800" y="3510000"/>
-            <a:ext cx="5032800" cy="2718000"/>
+            <a:ext cx="5032800" cy="2736000"/>
           </a:xfrm>
           <a:prstGeom prst="roundRect">
             <a:avLst>
@@ -10061,7 +9562,7 @@
         <p:spPr>
           <a:xfrm>
             <a:off x="6508800" y="3582000"/>
-            <a:ext cx="4816800" cy="2574000"/>
+            <a:ext cx="4816800" cy="2592000"/>
           </a:xfrm>
           <a:prstGeom prst="rect">
             <a:avLst/>
@@ -10081,7 +9582,7 @@
               </a:lnSpc>
             </a:pPr>
             <a:r>
-              <a:rPr sz="1150" b="1">
+              <a:rPr sz="1120" b="1">
                 <a:solidFill>
                   <a:srgbClr val="1E3A8A"/>
                 </a:solidFill>
@@ -10094,14 +9595,14 @@
           <a:p>
             <a:pPr>
               <a:lnSpc>
-                <a:spcPct val="122000"/>
+                <a:spcPct val="118000"/>
               </a:lnSpc>
               <a:spcBef>
-                <a:spcPts val="500"/>
+                <a:spcPts val="400"/>
               </a:spcBef>
             </a:pPr>
             <a:r>
-              <a:rPr sz="1019" b="1">
+              <a:rPr sz="1000" b="1">
                 <a:solidFill>
                   <a:srgbClr val="1E293B"/>
                 </a:solidFill>
@@ -10112,7 +9613,7 @@
 </a:t>
             </a:r>
             <a:r>
-              <a:rPr sz="980">
+              <a:rPr sz="950">
                 <a:solidFill>
                   <a:srgbClr val="334155"/>
                 </a:solidFill>
@@ -10125,14 +9626,14 @@
           <a:p>
             <a:pPr>
               <a:lnSpc>
-                <a:spcPct val="122000"/>
+                <a:spcPct val="118000"/>
               </a:lnSpc>
               <a:spcBef>
-                <a:spcPts val="500"/>
+                <a:spcPts val="400"/>
               </a:spcBef>
             </a:pPr>
             <a:r>
-              <a:rPr sz="1019" b="1">
+              <a:rPr sz="1000" b="1">
                 <a:solidFill>
                   <a:srgbClr val="1E293B"/>
                 </a:solidFill>
@@ -10143,7 +9644,7 @@
 </a:t>
             </a:r>
             <a:r>
-              <a:rPr sz="980">
+              <a:rPr sz="950">
                 <a:solidFill>
                   <a:srgbClr val="334155"/>
                 </a:solidFill>
@@ -10156,14 +9657,14 @@
           <a:p>
             <a:pPr>
               <a:lnSpc>
-                <a:spcPct val="122000"/>
+                <a:spcPct val="118000"/>
               </a:lnSpc>
               <a:spcBef>
-                <a:spcPts val="500"/>
+                <a:spcPts val="400"/>
               </a:spcBef>
             </a:pPr>
             <a:r>
-              <a:rPr sz="1019" b="1">
+              <a:rPr sz="1000" b="1">
                 <a:solidFill>
                   <a:srgbClr val="1E293B"/>
                 </a:solidFill>
@@ -10174,7 +9675,7 @@
 </a:t>
             </a:r>
             <a:r>
-              <a:rPr sz="980">
+              <a:rPr sz="950">
                 <a:solidFill>
                   <a:srgbClr val="334155"/>
                 </a:solidFill>
@@ -10400,7 +9901,7 @@
         <p:spPr>
           <a:xfrm>
             <a:off x="756000" y="1116000"/>
-            <a:ext cx="5032800" cy="216000"/>
+            <a:ext cx="5032800" cy="198000"/>
           </a:xfrm>
           <a:prstGeom prst="rect">
             <a:avLst/>
@@ -10436,7 +9937,7 @@
         <p:spPr>
           <a:xfrm>
             <a:off x="756000" y="1367999"/>
-            <a:ext cx="5032800" cy="251999"/>
+            <a:ext cx="5032800" cy="378000"/>
           </a:xfrm>
           <a:prstGeom prst="rect">
             <a:avLst/>
@@ -10445,7 +9946,7 @@
           <a:effectLst/>
         </p:spPr>
         <p:txBody>
-          <a:bodyPr wrap="square">
+          <a:bodyPr wrap="square" lIns="0" rIns="0" tIns="0" bIns="0">
             <a:spAutoFit/>
           </a:bodyPr>
           <a:lstStyle/>
@@ -10463,11 +9964,20 @@
                 <a:latin typeface="Segoe UI"/>
                 <a:ea typeface="Microsoft YaHei"/>
               </a:rPr>
-              <a:t>• 固定总样本规模预算 B = T · m 下的方差解构：
-</a:t>
-            </a:r>
-            <a:r>
-              <a:rPr sz="980">
+              <a:t>• 固定总样本规模预算 B = T · m 下的方差解构：</a:t>
+            </a:r>
+          </a:p>
+          <a:p>
+            <a:pPr>
+              <a:lnSpc>
+                <a:spcPct val="115000"/>
+              </a:lnSpc>
+              <a:spcBef>
+                <a:spcPts val="200"/>
+              </a:spcBef>
+            </a:pPr>
+            <a:r>
+              <a:rPr sz="960">
                 <a:solidFill>
                   <a:srgbClr val="334155"/>
                 </a:solidFill>
@@ -10487,8 +9997,8 @@
         </p:nvSpPr>
         <p:spPr>
           <a:xfrm>
-            <a:off x="756000" y="1691999"/>
-            <a:ext cx="5032800" cy="450000"/>
+            <a:off x="756000" y="1764000"/>
+            <a:ext cx="5032800" cy="413999"/>
           </a:xfrm>
           <a:prstGeom prst="roundRect">
             <a:avLst>
@@ -10515,22 +10025,22 @@
       </p:sp>
       <p:pic>
         <p:nvPicPr>
-          <p:cNvPr id="10" name="Picture 9" descr="s4_budget_constant.png"/>
+          <p:cNvPr id="10" name="Picture 9" descr="image.png"/>
           <p:cNvPicPr>
             <a:picLocks noChangeAspect="1"/>
           </p:cNvPicPr>
           <p:nvPr/>
         </p:nvPicPr>
         <p:blipFill>
-          <a:blip r:embed="rId5"/>
+          <a:blip r:embed="rId9"/>
           <a:stretch>
             <a:fillRect/>
           </a:stretch>
         </p:blipFill>
         <p:spPr>
           <a:xfrm>
-            <a:off x="864000" y="1809937"/>
-            <a:ext cx="4816800" cy="214123"/>
+            <a:off x="2031094" y="1807200"/>
+            <a:ext cx="2482610" cy="327599"/>
           </a:xfrm>
           <a:prstGeom prst="rect">
             <a:avLst/>
@@ -10546,8 +10056,8 @@
         </p:nvSpPr>
         <p:spPr>
           <a:xfrm>
-            <a:off x="756000" y="2214000"/>
-            <a:ext cx="5032800" cy="1152000"/>
+            <a:off x="756000" y="2250000"/>
+            <a:ext cx="5032800" cy="1098000"/>
           </a:xfrm>
           <a:prstGeom prst="roundRect">
             <a:avLst>
@@ -10580,8 +10090,8 @@
         </p:nvSpPr>
         <p:spPr>
           <a:xfrm>
-            <a:off x="900000" y="2286000"/>
-            <a:ext cx="4744800" cy="1008000"/>
+            <a:off x="900000" y="2322000"/>
+            <a:ext cx="4744800" cy="954000"/>
           </a:xfrm>
           <a:prstGeom prst="rect">
             <a:avLst/>
@@ -10597,21 +10107,31 @@
           <a:p>
             <a:pPr>
               <a:lnSpc>
-                <a:spcPct val="122000"/>
-              </a:lnSpc>
-            </a:pPr>
-            <a:r>
-              <a:rPr sz="1100" b="1">
+                <a:spcPct val="115000"/>
+              </a:lnSpc>
+            </a:pPr>
+            <a:r>
+              <a:rPr sz="1080" b="1">
                 <a:solidFill>
                   <a:srgbClr val="1E3A8A"/>
                 </a:solidFill>
                 <a:latin typeface="Segoe UI"/>
                 <a:ea typeface="Microsoft YaHei"/>
               </a:rPr>
-              <a:t>【样本预算恒常性定理 (Invariance of Sampling Variance)】  </a:t>
-            </a:r>
-            <a:r>
-              <a:rPr sz="980">
+              <a:t>【样本预算恒常性定理 (Invariance of Sampling Variance)】</a:t>
+            </a:r>
+          </a:p>
+          <a:p>
+            <a:pPr>
+              <a:lnSpc>
+                <a:spcPct val="118000"/>
+              </a:lnSpc>
+              <a:spcBef>
+                <a:spcPts val="300"/>
+              </a:spcBef>
+            </a:pPr>
+            <a:r>
+              <a:rPr sz="950">
                 <a:solidFill>
                   <a:srgbClr val="334155"/>
                 </a:solidFill>
@@ -10631,8 +10151,8 @@
         </p:nvSpPr>
         <p:spPr>
           <a:xfrm>
-            <a:off x="756000" y="3438000"/>
-            <a:ext cx="5032800" cy="2790000"/>
+            <a:off x="756000" y="3420000"/>
+            <a:ext cx="5032800" cy="2826000"/>
           </a:xfrm>
           <a:prstGeom prst="roundRect">
             <a:avLst>
@@ -10665,8 +10185,8 @@
         </p:nvSpPr>
         <p:spPr>
           <a:xfrm>
-            <a:off x="864000" y="3510000"/>
-            <a:ext cx="4816800" cy="2646000"/>
+            <a:off x="864000" y="3492000"/>
+            <a:ext cx="4816800" cy="2682000"/>
           </a:xfrm>
           <a:prstGeom prst="rect">
             <a:avLst/>
@@ -10686,7 +10206,7 @@
               </a:lnSpc>
             </a:pPr>
             <a:r>
-              <a:rPr sz="1150" b="1">
+              <a:rPr sz="1120" b="1">
                 <a:solidFill>
                   <a:srgbClr val="1E3A8A"/>
                 </a:solidFill>
@@ -10699,14 +10219,14 @@
           <a:p>
             <a:pPr>
               <a:lnSpc>
-                <a:spcPct val="122000"/>
+                <a:spcPct val="118000"/>
               </a:lnSpc>
               <a:spcBef>
-                <a:spcPts val="500"/>
+                <a:spcPts val="400"/>
               </a:spcBef>
             </a:pPr>
             <a:r>
-              <a:rPr sz="1019" b="1">
+              <a:rPr sz="1000" b="1">
                 <a:solidFill>
                   <a:srgbClr val="1E293B"/>
                 </a:solidFill>
@@ -10717,7 +10237,7 @@
 </a:t>
             </a:r>
             <a:r>
-              <a:rPr sz="980">
+              <a:rPr sz="950">
                 <a:solidFill>
                   <a:srgbClr val="334155"/>
                 </a:solidFill>
@@ -10730,14 +10250,14 @@
           <a:p>
             <a:pPr>
               <a:lnSpc>
-                <a:spcPct val="122000"/>
+                <a:spcPct val="118000"/>
               </a:lnSpc>
               <a:spcBef>
-                <a:spcPts val="500"/>
+                <a:spcPts val="400"/>
               </a:spcBef>
             </a:pPr>
             <a:r>
-              <a:rPr sz="1019" b="1">
+              <a:rPr sz="1000" b="1">
                 <a:solidFill>
                   <a:srgbClr val="1E293B"/>
                 </a:solidFill>
@@ -10748,7 +10268,7 @@
 </a:t>
             </a:r>
             <a:r>
-              <a:rPr sz="980">
+              <a:rPr sz="950">
                 <a:solidFill>
                   <a:srgbClr val="334155"/>
                 </a:solidFill>
@@ -10761,14 +10281,14 @@
           <a:p>
             <a:pPr>
               <a:lnSpc>
-                <a:spcPct val="122000"/>
+                <a:spcPct val="118000"/>
               </a:lnSpc>
               <a:spcBef>
-                <a:spcPts val="500"/>
+                <a:spcPts val="400"/>
               </a:spcBef>
             </a:pPr>
             <a:r>
-              <a:rPr sz="1019" b="1">
+              <a:rPr sz="1000" b="1">
                 <a:solidFill>
                   <a:srgbClr val="1E293B"/>
                 </a:solidFill>
@@ -10779,7 +10299,7 @@
 </a:t>
             </a:r>
             <a:r>
-              <a:rPr sz="980">
+              <a:rPr sz="950">
                 <a:solidFill>
                   <a:srgbClr val="334155"/>
                 </a:solidFill>
@@ -10834,7 +10354,7 @@
         <p:spPr>
           <a:xfrm>
             <a:off x="6400800" y="1116000"/>
-            <a:ext cx="5032800" cy="216000"/>
+            <a:ext cx="5032800" cy="198000"/>
           </a:xfrm>
           <a:prstGeom prst="rect">
             <a:avLst/>
@@ -10870,7 +10390,7 @@
         <p:spPr>
           <a:xfrm>
             <a:off x="6400800" y="1367999"/>
-            <a:ext cx="5032800" cy="251999"/>
+            <a:ext cx="5032800" cy="378000"/>
           </a:xfrm>
           <a:prstGeom prst="rect">
             <a:avLst/>
@@ -10879,7 +10399,7 @@
           <a:effectLst/>
         </p:spPr>
         <p:txBody>
-          <a:bodyPr wrap="square">
+          <a:bodyPr wrap="square" lIns="0" rIns="0" tIns="0" bIns="0">
             <a:spAutoFit/>
           </a:bodyPr>
           <a:lstStyle/>
@@ -10897,11 +10417,20 @@
                 <a:latin typeface="Segoe UI"/>
                 <a:ea typeface="Microsoft YaHei"/>
               </a:rPr>
-              <a:t>• 显式经济成本模型与目标方差函数：
-</a:t>
-            </a:r>
-            <a:r>
-              <a:rPr sz="980">
+              <a:t>• 显式经济成本模型与目标方差函数：</a:t>
+            </a:r>
+          </a:p>
+          <a:p>
+            <a:pPr>
+              <a:lnSpc>
+                <a:spcPct val="115000"/>
+              </a:lnSpc>
+              <a:spcBef>
+                <a:spcPts val="200"/>
+              </a:spcBef>
+            </a:pPr>
+            <a:r>
+              <a:rPr sz="960">
                 <a:solidFill>
                   <a:srgbClr val="334155"/>
                 </a:solidFill>
@@ -10921,8 +10450,8 @@
         </p:nvSpPr>
         <p:spPr>
           <a:xfrm>
-            <a:off x="6400800" y="1691999"/>
-            <a:ext cx="5032800" cy="450000"/>
+            <a:off x="6400800" y="1764000"/>
+            <a:ext cx="5032800" cy="413999"/>
           </a:xfrm>
           <a:prstGeom prst="roundRect">
             <a:avLst>
@@ -10949,22 +10478,22 @@
       </p:sp>
       <p:pic>
         <p:nvPicPr>
-          <p:cNvPr id="19" name="Picture 18" descr="s4_cochran_optimal.png"/>
+          <p:cNvPr id="19" name="Picture 18" descr="image.png"/>
           <p:cNvPicPr>
             <a:picLocks noChangeAspect="1"/>
           </p:cNvPicPr>
           <p:nvPr/>
         </p:nvPicPr>
         <p:blipFill>
-          <a:blip r:embed="rId6"/>
+          <a:blip r:embed="rId10"/>
           <a:stretch>
             <a:fillRect/>
           </a:stretch>
         </p:blipFill>
         <p:spPr>
           <a:xfrm>
-            <a:off x="6508800" y="1811619"/>
-            <a:ext cx="4816800" cy="210758"/>
+            <a:off x="7545057" y="1807200"/>
+            <a:ext cx="2744284" cy="327599"/>
           </a:xfrm>
           <a:prstGeom prst="rect">
             <a:avLst/>
@@ -10980,8 +10509,8 @@
         </p:nvSpPr>
         <p:spPr>
           <a:xfrm>
-            <a:off x="6400800" y="2214000"/>
-            <a:ext cx="5032800" cy="4014000"/>
+            <a:off x="6400800" y="2250000"/>
+            <a:ext cx="5032800" cy="3996000"/>
           </a:xfrm>
           <a:prstGeom prst="roundRect">
             <a:avLst>
@@ -11014,8 +10543,8 @@
         </p:nvSpPr>
         <p:spPr>
           <a:xfrm>
-            <a:off x="6508800" y="2286000"/>
-            <a:ext cx="4816800" cy="3870000"/>
+            <a:off x="6508800" y="2322000"/>
+            <a:ext cx="4816800" cy="3851999"/>
           </a:xfrm>
           <a:prstGeom prst="rect">
             <a:avLst/>
@@ -11035,7 +10564,7 @@
               </a:lnSpc>
             </a:pPr>
             <a:r>
-              <a:rPr sz="1150" b="1">
+              <a:rPr sz="1120" b="1">
                 <a:solidFill>
                   <a:srgbClr val="1E3A8A"/>
                 </a:solidFill>
@@ -11048,14 +10577,14 @@
           <a:p>
             <a:pPr>
               <a:lnSpc>
-                <a:spcPct val="122000"/>
+                <a:spcPct val="118000"/>
               </a:lnSpc>
               <a:spcBef>
-                <a:spcPts val="500"/>
+                <a:spcPts val="400"/>
               </a:spcBef>
             </a:pPr>
             <a:r>
-              <a:rPr sz="1019" b="1">
+              <a:rPr sz="1000" b="1">
                 <a:solidFill>
                   <a:srgbClr val="1E293B"/>
                 </a:solidFill>
@@ -11066,7 +10595,7 @@
 </a:t>
             </a:r>
             <a:r>
-              <a:rPr sz="980">
+              <a:rPr sz="950">
                 <a:solidFill>
                   <a:srgbClr val="334155"/>
                 </a:solidFill>
@@ -11079,14 +10608,14 @@
           <a:p>
             <a:pPr>
               <a:lnSpc>
-                <a:spcPct val="122000"/>
+                <a:spcPct val="118000"/>
               </a:lnSpc>
               <a:spcBef>
-                <a:spcPts val="500"/>
+                <a:spcPts val="400"/>
               </a:spcBef>
             </a:pPr>
             <a:r>
-              <a:rPr sz="1019" b="1">
+              <a:rPr sz="1000" b="1">
                 <a:solidFill>
                   <a:srgbClr val="1E293B"/>
                 </a:solidFill>
@@ -11097,7 +10626,7 @@
 </a:t>
             </a:r>
             <a:r>
-              <a:rPr sz="980">
+              <a:rPr sz="950">
                 <a:solidFill>
                   <a:srgbClr val="334155"/>
                 </a:solidFill>
@@ -11110,14 +10639,14 @@
           <a:p>
             <a:pPr>
               <a:lnSpc>
-                <a:spcPct val="122000"/>
+                <a:spcPct val="118000"/>
               </a:lnSpc>
               <a:spcBef>
-                <a:spcPts val="500"/>
+                <a:spcPts val="400"/>
               </a:spcBef>
             </a:pPr>
             <a:r>
-              <a:rPr sz="1019" b="1">
+              <a:rPr sz="1000" b="1">
                 <a:solidFill>
                   <a:srgbClr val="1E293B"/>
                 </a:solidFill>
@@ -11128,7 +10657,7 @@
 </a:t>
             </a:r>
             <a:r>
-              <a:rPr sz="980">
+              <a:rPr sz="950">
                 <a:solidFill>
                   <a:srgbClr val="334155"/>
                 </a:solidFill>
@@ -11141,14 +10670,14 @@
           <a:p>
             <a:pPr>
               <a:lnSpc>
-                <a:spcPct val="122000"/>
+                <a:spcPct val="118000"/>
               </a:lnSpc>
               <a:spcBef>
-                <a:spcPts val="500"/>
+                <a:spcPts val="400"/>
               </a:spcBef>
             </a:pPr>
             <a:r>
-              <a:rPr sz="1019" b="1">
+              <a:rPr sz="1000" b="1">
                 <a:solidFill>
                   <a:srgbClr val="1E293B"/>
                 </a:solidFill>
@@ -11159,7 +10688,7 @@
 </a:t>
             </a:r>
             <a:r>
-              <a:rPr sz="980">
+              <a:rPr sz="950">
                 <a:solidFill>
                   <a:srgbClr val="334155"/>
                 </a:solidFill>
@@ -11385,7 +10914,7 @@
         <p:spPr>
           <a:xfrm>
             <a:off x="756000" y="1116000"/>
-            <a:ext cx="4176000" cy="216000"/>
+            <a:ext cx="4176000" cy="198000"/>
           </a:xfrm>
           <a:prstGeom prst="rect">
             <a:avLst/>
@@ -11491,15 +11020,15 @@
           <p:nvPr/>
         </p:nvPicPr>
         <p:blipFill>
-          <a:blip r:embed="rId2"/>
+          <a:blip r:embed="rId7"/>
           <a:stretch>
             <a:fillRect/>
           </a:stretch>
         </p:blipFill>
         <p:spPr>
           <a:xfrm>
-            <a:off x="1637645" y="1591200"/>
-            <a:ext cx="2412709" cy="291600"/>
+            <a:off x="1534853" y="1591200"/>
+            <a:ext cx="2618293" cy="291600"/>
           </a:xfrm>
           <a:prstGeom prst="rect">
             <a:avLst/>
@@ -11586,15 +11115,15 @@
           <p:nvPr/>
         </p:nvPicPr>
         <p:blipFill>
-          <a:blip r:embed="rId3"/>
+          <a:blip r:embed="rId8"/>
           <a:stretch>
             <a:fillRect/>
           </a:stretch>
         </p:blipFill>
         <p:spPr>
           <a:xfrm>
-            <a:off x="1795565" y="2185200"/>
-            <a:ext cx="2096869" cy="291600"/>
+            <a:off x="1640959" y="2185200"/>
+            <a:ext cx="2406081" cy="291600"/>
           </a:xfrm>
           <a:prstGeom prst="rect">
             <a:avLst/>
@@ -11647,7 +11176,7 @@
         <p:spPr>
           <a:xfrm>
             <a:off x="756000" y="2736000"/>
-            <a:ext cx="4176000" cy="413999"/>
+            <a:ext cx="4176000" cy="378000"/>
           </a:xfrm>
           <a:prstGeom prst="roundRect">
             <a:avLst>
@@ -11674,22 +11203,22 @@
       </p:sp>
       <p:pic>
         <p:nvPicPr>
-          <p:cNvPr id="16" name="Picture 15" descr="s5_renewal_decomp.png"/>
+          <p:cNvPr id="16" name="Picture 15" descr="image.png"/>
           <p:cNvPicPr>
             <a:picLocks noChangeAspect="1"/>
           </p:cNvPicPr>
           <p:nvPr/>
         </p:nvPicPr>
         <p:blipFill>
-          <a:blip r:embed="rId4"/>
+          <a:blip r:embed="rId9"/>
           <a:stretch>
             <a:fillRect/>
           </a:stretch>
         </p:blipFill>
         <p:spPr>
           <a:xfrm>
-            <a:off x="864000" y="2875191"/>
-            <a:ext cx="3960000" cy="135616"/>
+            <a:off x="1623402" y="2779200"/>
+            <a:ext cx="2441195" cy="291600"/>
           </a:xfrm>
           <a:prstGeom prst="rect">
             <a:avLst/>
@@ -11705,8 +11234,8 @@
         </p:nvSpPr>
         <p:spPr>
           <a:xfrm>
-            <a:off x="756000" y="3204000"/>
-            <a:ext cx="4176000" cy="3024000"/>
+            <a:off x="756000" y="3186000"/>
+            <a:ext cx="4176000" cy="3060000"/>
           </a:xfrm>
           <a:prstGeom prst="roundRect">
             <a:avLst>
@@ -11739,8 +11268,8 @@
         </p:nvSpPr>
         <p:spPr>
           <a:xfrm>
-            <a:off x="864000" y="3276000"/>
-            <a:ext cx="3960000" cy="2880000"/>
+            <a:off x="864000" y="3258000"/>
+            <a:ext cx="3960000" cy="2916000"/>
           </a:xfrm>
           <a:prstGeom prst="rect">
             <a:avLst/>
@@ -11760,7 +11289,7 @@
               </a:lnSpc>
             </a:pPr>
             <a:r>
-              <a:rPr sz="1150" b="1">
+              <a:rPr sz="1120" b="1">
                 <a:solidFill>
                   <a:srgbClr val="1E3A8A"/>
                 </a:solidFill>
@@ -11773,14 +11302,14 @@
           <a:p>
             <a:pPr>
               <a:lnSpc>
-                <a:spcPct val="120000"/>
+                <a:spcPct val="118000"/>
               </a:lnSpc>
               <a:spcBef>
                 <a:spcPts val="400"/>
               </a:spcBef>
             </a:pPr>
             <a:r>
-              <a:rPr sz="1019" b="1">
+              <a:rPr sz="1000" b="1">
                 <a:solidFill>
                   <a:srgbClr val="1E293B"/>
                 </a:solidFill>
@@ -11791,7 +11320,7 @@
 </a:t>
             </a:r>
             <a:r>
-              <a:rPr sz="980">
+              <a:rPr sz="950">
                 <a:solidFill>
                   <a:srgbClr val="334155"/>
                 </a:solidFill>
@@ -11804,14 +11333,14 @@
           <a:p>
             <a:pPr>
               <a:lnSpc>
-                <a:spcPct val="120000"/>
+                <a:spcPct val="118000"/>
               </a:lnSpc>
               <a:spcBef>
                 <a:spcPts val="400"/>
               </a:spcBef>
             </a:pPr>
             <a:r>
-              <a:rPr sz="1019" b="1">
+              <a:rPr sz="1000" b="1">
                 <a:solidFill>
                   <a:srgbClr val="1E293B"/>
                 </a:solidFill>
@@ -11822,7 +11351,7 @@
 </a:t>
             </a:r>
             <a:r>
-              <a:rPr sz="980">
+              <a:rPr sz="950">
                 <a:solidFill>
                   <a:srgbClr val="334155"/>
                 </a:solidFill>
@@ -11835,14 +11364,14 @@
           <a:p>
             <a:pPr>
               <a:lnSpc>
-                <a:spcPct val="120000"/>
+                <a:spcPct val="118000"/>
               </a:lnSpc>
               <a:spcBef>
                 <a:spcPts val="400"/>
               </a:spcBef>
             </a:pPr>
             <a:r>
-              <a:rPr sz="1019" b="1">
+              <a:rPr sz="1000" b="1">
                 <a:solidFill>
                   <a:srgbClr val="1E293B"/>
                 </a:solidFill>
@@ -11853,7 +11382,7 @@
 </a:t>
             </a:r>
             <a:r>
-              <a:rPr sz="980">
+              <a:rPr sz="950">
                 <a:solidFill>
                   <a:srgbClr val="334155"/>
                 </a:solidFill>
@@ -11967,7 +11496,7 @@
         <p:spPr>
           <a:xfrm>
             <a:off x="5544000" y="3330000"/>
-            <a:ext cx="5893200" cy="180000"/>
+            <a:ext cx="5893200" cy="162000"/>
           </a:xfrm>
           <a:prstGeom prst="rect">
             <a:avLst/>
@@ -11982,7 +11511,7 @@
           <a:lstStyle/>
           <a:p>
             <a:r>
-              <a:rPr sz="1150" b="1">
+              <a:rPr sz="1120" b="1">
                 <a:solidFill>
                   <a:srgbClr val="1E3A8A"/>
                 </a:solidFill>
@@ -12002,7 +11531,7 @@
         </p:nvSpPr>
         <p:spPr>
           <a:xfrm>
-            <a:off x="5544000" y="3564000"/>
+            <a:off x="5544000" y="3546000"/>
             <a:ext cx="5893200" cy="666000"/>
           </a:xfrm>
           <a:prstGeom prst="roundRect">
@@ -12036,7 +11565,7 @@
         </p:nvSpPr>
         <p:spPr>
           <a:xfrm>
-            <a:off x="5688000" y="3636000"/>
+            <a:off x="5688000" y="3618000"/>
             <a:ext cx="5605200" cy="522000"/>
           </a:xfrm>
           <a:prstGeom prst="rect">
@@ -12053,11 +11582,11 @@
           <a:p>
             <a:pPr>
               <a:lnSpc>
-                <a:spcPct val="122000"/>
-              </a:lnSpc>
-            </a:pPr>
-            <a:r>
-              <a:rPr sz="1100" b="1">
+                <a:spcPct val="115000"/>
+              </a:lnSpc>
+            </a:pPr>
+            <a:r>
+              <a:rPr sz="1080" b="1">
                 <a:solidFill>
                   <a:srgbClr val="1E3A8A"/>
                 </a:solidFill>
@@ -12067,7 +11596,7 @@
               <a:t>1. Wald 正态近似失真  </a:t>
             </a:r>
             <a:r>
-              <a:rPr sz="980">
+              <a:rPr sz="950">
                 <a:solidFill>
                   <a:srgbClr val="334155"/>
                 </a:solidFill>
@@ -12087,7 +11616,7 @@
         </p:nvSpPr>
         <p:spPr>
           <a:xfrm>
-            <a:off x="5544000" y="4302000"/>
+            <a:off x="5544000" y="4276800"/>
             <a:ext cx="5893200" cy="666000"/>
           </a:xfrm>
           <a:prstGeom prst="roundRect">
@@ -12121,7 +11650,7 @@
         </p:nvSpPr>
         <p:spPr>
           <a:xfrm>
-            <a:off x="5688000" y="4374000"/>
+            <a:off x="5688000" y="4348800"/>
             <a:ext cx="5605200" cy="522000"/>
           </a:xfrm>
           <a:prstGeom prst="rect">
@@ -12138,11 +11667,11 @@
           <a:p>
             <a:pPr>
               <a:lnSpc>
-                <a:spcPct val="122000"/>
-              </a:lnSpc>
-            </a:pPr>
-            <a:r>
-              <a:rPr sz="1100" b="1">
+                <a:spcPct val="115000"/>
+              </a:lnSpc>
+            </a:pPr>
+            <a:r>
+              <a:rPr sz="1080" b="1">
                 <a:solidFill>
                   <a:srgbClr val="1E3A8A"/>
                 </a:solidFill>
@@ -12152,7 +11681,7 @@
               <a:t>2. 超传播惩罚因子  </a:t>
             </a:r>
             <a:r>
-              <a:rPr sz="980">
+              <a:rPr sz="950">
                 <a:solidFill>
                   <a:srgbClr val="334155"/>
                 </a:solidFill>
@@ -12172,7 +11701,7 @@
         </p:nvSpPr>
         <p:spPr>
           <a:xfrm>
-            <a:off x="5544000" y="5040000"/>
+            <a:off x="5544000" y="5007600"/>
             <a:ext cx="5893200" cy="666000"/>
           </a:xfrm>
           <a:prstGeom prst="roundRect">
@@ -12206,7 +11735,7 @@
         </p:nvSpPr>
         <p:spPr>
           <a:xfrm>
-            <a:off x="5688000" y="5112000"/>
+            <a:off x="5688000" y="5079600"/>
             <a:ext cx="5605200" cy="522000"/>
           </a:xfrm>
           <a:prstGeom prst="rect">
@@ -12223,11 +11752,11 @@
           <a:p>
             <a:pPr>
               <a:lnSpc>
-                <a:spcPct val="122000"/>
-              </a:lnSpc>
-            </a:pPr>
-            <a:r>
-              <a:rPr sz="1100" b="1">
+                <a:spcPct val="115000"/>
+              </a:lnSpc>
+            </a:pPr>
+            <a:r>
+              <a:rPr sz="1080" b="1">
                 <a:solidFill>
                   <a:srgbClr val="1E3A8A"/>
                 </a:solidFill>
@@ -12237,7 +11766,7 @@
               <a:t>3. 边际削减规律验证  </a:t>
             </a:r>
             <a:r>
-              <a:rPr sz="980">
+              <a:rPr sz="950">
                 <a:solidFill>
                   <a:srgbClr val="334155"/>
                 </a:solidFill>
@@ -12308,21 +11837,31 @@
           <a:p>
             <a:pPr>
               <a:lnSpc>
-                <a:spcPct val="122000"/>
-              </a:lnSpc>
-            </a:pPr>
-            <a:r>
-              <a:rPr sz="1100" b="1">
+                <a:spcPct val="115000"/>
+              </a:lnSpc>
+            </a:pPr>
+            <a:r>
+              <a:rPr sz="1080" b="1">
                 <a:solidFill>
                   <a:srgbClr val="1E3A8A"/>
                 </a:solidFill>
                 <a:latin typeface="Segoe UI"/>
                 <a:ea typeface="Microsoft YaHei"/>
               </a:rPr>
-              <a:t>【哨点设计定量判据】  </a:t>
-            </a:r>
-            <a:r>
-              <a:rPr sz="980">
+              <a:t>【哨点设计定量判据】</a:t>
+            </a:r>
+          </a:p>
+          <a:p>
+            <a:pPr>
+              <a:lnSpc>
+                <a:spcPct val="118000"/>
+              </a:lnSpc>
+              <a:spcBef>
+                <a:spcPts val="300"/>
+              </a:spcBef>
+            </a:pPr>
+            <a:r>
+              <a:rPr sz="950">
                 <a:solidFill>
                   <a:srgbClr val="334155"/>
                 </a:solidFill>
@@ -12548,7 +12087,7 @@
         <p:spPr>
           <a:xfrm>
             <a:off x="756000" y="1116000"/>
-            <a:ext cx="4176000" cy="216000"/>
+            <a:ext cx="4176000" cy="198000"/>
           </a:xfrm>
           <a:prstGeom prst="rect">
             <a:avLst/>
@@ -12654,15 +12193,15 @@
           <p:nvPr/>
         </p:nvPicPr>
         <p:blipFill>
-          <a:blip r:embed="rId2"/>
+          <a:blip r:embed="rId5"/>
           <a:stretch>
             <a:fillRect/>
           </a:stretch>
         </p:blipFill>
         <p:spPr>
           <a:xfrm>
-            <a:off x="2093971" y="1591200"/>
-            <a:ext cx="1500057" cy="291600"/>
+            <a:off x="2031794" y="1591200"/>
+            <a:ext cx="1624410" cy="291600"/>
           </a:xfrm>
           <a:prstGeom prst="rect">
             <a:avLst/>
@@ -12714,7 +12253,7 @@
         </p:nvSpPr>
         <p:spPr>
           <a:xfrm>
-            <a:off x="756000" y="2142000"/>
+            <a:off x="756000" y="2160000"/>
             <a:ext cx="4176000" cy="413999"/>
           </a:xfrm>
           <a:prstGeom prst="roundRect">
@@ -12749,15 +12288,15 @@
           <p:nvPr/>
         </p:nvPicPr>
         <p:blipFill>
-          <a:blip r:embed="rId3"/>
+          <a:blip r:embed="rId6"/>
           <a:stretch>
             <a:fillRect/>
           </a:stretch>
         </p:blipFill>
         <p:spPr>
           <a:xfrm>
-            <a:off x="1486354" y="2185200"/>
-            <a:ext cx="2715291" cy="327599"/>
+            <a:off x="1370662" y="2203200"/>
+            <a:ext cx="2946675" cy="327599"/>
           </a:xfrm>
           <a:prstGeom prst="rect">
             <a:avLst/>
@@ -12773,7 +12312,7 @@
         </p:nvSpPr>
         <p:spPr>
           <a:xfrm>
-            <a:off x="756000" y="2628000"/>
+            <a:off x="756000" y="2646000"/>
             <a:ext cx="4176000" cy="3600000"/>
           </a:xfrm>
           <a:prstGeom prst="roundRect">
@@ -12807,7 +12346,7 @@
         </p:nvSpPr>
         <p:spPr>
           <a:xfrm>
-            <a:off x="864000" y="2699999"/>
+            <a:off x="864000" y="2718000"/>
             <a:ext cx="3960000" cy="3456000"/>
           </a:xfrm>
           <a:prstGeom prst="rect">
@@ -12828,7 +12367,7 @@
               </a:lnSpc>
             </a:pPr>
             <a:r>
-              <a:rPr sz="1150" b="1">
+              <a:rPr sz="1120" b="1">
                 <a:solidFill>
                   <a:srgbClr val="1E3A8A"/>
                 </a:solidFill>
@@ -12841,14 +12380,14 @@
           <a:p>
             <a:pPr>
               <a:lnSpc>
-                <a:spcPct val="120000"/>
+                <a:spcPct val="118000"/>
               </a:lnSpc>
               <a:spcBef>
                 <a:spcPts val="400"/>
               </a:spcBef>
             </a:pPr>
             <a:r>
-              <a:rPr sz="1019" b="1">
+              <a:rPr sz="1000" b="1">
                 <a:solidFill>
                   <a:srgbClr val="1E293B"/>
                 </a:solidFill>
@@ -12859,7 +12398,7 @@
 </a:t>
             </a:r>
             <a:r>
-              <a:rPr sz="980">
+              <a:rPr sz="950">
                 <a:solidFill>
                   <a:srgbClr val="334155"/>
                 </a:solidFill>
@@ -12872,14 +12411,14 @@
           <a:p>
             <a:pPr>
               <a:lnSpc>
-                <a:spcPct val="120000"/>
+                <a:spcPct val="118000"/>
               </a:lnSpc>
               <a:spcBef>
                 <a:spcPts val="400"/>
               </a:spcBef>
             </a:pPr>
             <a:r>
-              <a:rPr sz="1019" b="1">
+              <a:rPr sz="1000" b="1">
                 <a:solidFill>
                   <a:srgbClr val="1E293B"/>
                 </a:solidFill>
@@ -12890,7 +12429,7 @@
 </a:t>
             </a:r>
             <a:r>
-              <a:rPr sz="980">
+              <a:rPr sz="950">
                 <a:solidFill>
                   <a:srgbClr val="334155"/>
                 </a:solidFill>
@@ -12903,14 +12442,14 @@
           <a:p>
             <a:pPr>
               <a:lnSpc>
-                <a:spcPct val="120000"/>
+                <a:spcPct val="118000"/>
               </a:lnSpc>
               <a:spcBef>
                 <a:spcPts val="400"/>
               </a:spcBef>
             </a:pPr>
             <a:r>
-              <a:rPr sz="1019" b="1">
+              <a:rPr sz="1000" b="1">
                 <a:solidFill>
                   <a:srgbClr val="1E293B"/>
                 </a:solidFill>
@@ -12921,7 +12460,7 @@
 </a:t>
             </a:r>
             <a:r>
-              <a:rPr sz="980">
+              <a:rPr sz="950">
                 <a:solidFill>
                   <a:srgbClr val="334155"/>
                 </a:solidFill>
@@ -12934,14 +12473,14 @@
           <a:p>
             <a:pPr>
               <a:lnSpc>
-                <a:spcPct val="120000"/>
+                <a:spcPct val="118000"/>
               </a:lnSpc>
               <a:spcBef>
                 <a:spcPts val="400"/>
               </a:spcBef>
             </a:pPr>
             <a:r>
-              <a:rPr sz="1019" b="1">
+              <a:rPr sz="1000" b="1">
                 <a:solidFill>
                   <a:srgbClr val="1E293B"/>
                 </a:solidFill>
@@ -12952,7 +12491,7 @@
 </a:t>
             </a:r>
             <a:r>
-              <a:rPr sz="980">
+              <a:rPr sz="950">
                 <a:solidFill>
                   <a:srgbClr val="334155"/>
                 </a:solidFill>
@@ -13007,7 +12546,7 @@
         <p:spPr>
           <a:xfrm>
             <a:off x="5518800" y="1116000"/>
-            <a:ext cx="5940000" cy="3096000"/>
+            <a:ext cx="5940000" cy="2988000"/>
           </a:xfrm>
           <a:prstGeom prst="roundRect">
             <a:avLst>
@@ -13048,8 +12587,8 @@
         </p:blipFill>
         <p:spPr>
           <a:xfrm>
-            <a:off x="5608800" y="559413"/>
-            <a:ext cx="5760000" cy="4209173"/>
+            <a:off x="6518246" y="1170000"/>
+            <a:ext cx="3941106" cy="2880000"/>
           </a:xfrm>
           <a:prstGeom prst="rect">
             <a:avLst/>
@@ -13065,8 +12604,8 @@
         </p:nvSpPr>
         <p:spPr>
           <a:xfrm>
-            <a:off x="5544000" y="4265999"/>
-            <a:ext cx="5893200" cy="180000"/>
+            <a:off x="5544000" y="4158000"/>
+            <a:ext cx="5893200" cy="162000"/>
           </a:xfrm>
           <a:prstGeom prst="rect">
             <a:avLst/>
@@ -13081,7 +12620,7 @@
           <a:lstStyle/>
           <a:p>
             <a:r>
-              <a:rPr sz="1150" b="1">
+              <a:rPr sz="1120" b="1">
                 <a:solidFill>
                   <a:srgbClr val="1E3A8A"/>
                 </a:solidFill>
@@ -13101,8 +12640,8 @@
         </p:nvSpPr>
         <p:spPr>
           <a:xfrm>
-            <a:off x="5544000" y="4482000"/>
-            <a:ext cx="5893200" cy="1728000"/>
+            <a:off x="5544000" y="4374000"/>
+            <a:ext cx="5893200" cy="1872000"/>
           </a:xfrm>
           <a:prstGeom prst="roundRect">
             <a:avLst>
@@ -13135,8 +12674,8 @@
         </p:nvSpPr>
         <p:spPr>
           <a:xfrm>
-            <a:off x="5688000" y="4554000"/>
-            <a:ext cx="5605200" cy="1584000"/>
+            <a:off x="5688000" y="4446000"/>
+            <a:ext cx="5605200" cy="1728000"/>
           </a:xfrm>
           <a:prstGeom prst="rect">
             <a:avLst/>
@@ -13152,28 +12691,38 @@
           <a:p>
             <a:pPr>
               <a:lnSpc>
-                <a:spcPct val="122000"/>
-              </a:lnSpc>
-            </a:pPr>
-            <a:r>
-              <a:rPr sz="1100" b="1">
+                <a:spcPct val="115000"/>
+              </a:lnSpc>
+            </a:pPr>
+            <a:r>
+              <a:rPr sz="1080" b="1">
                 <a:solidFill>
                   <a:srgbClr val="1E3A8A"/>
                 </a:solidFill>
                 <a:latin typeface="Segoe UI"/>
                 <a:ea typeface="Microsoft YaHei"/>
               </a:rPr>
-              <a:t>【实证检验总结与大论文论证闭环】  </a:t>
-            </a:r>
-            <a:r>
-              <a:rPr sz="980">
+              <a:t>【实证检验总结与大论文论证闭环】</a:t>
+            </a:r>
+          </a:p>
+          <a:p>
+            <a:pPr>
+              <a:lnSpc>
+                <a:spcPct val="118000"/>
+              </a:lnSpc>
+              <a:spcBef>
+                <a:spcPts val="300"/>
+              </a:spcBef>
+            </a:pPr>
+            <a:r>
+              <a:rPr sz="950">
                 <a:solidFill>
                   <a:srgbClr val="334155"/>
                 </a:solidFill>
                 <a:latin typeface="Segoe UI"/>
                 <a:ea typeface="Microsoft YaHei"/>
               </a:rPr>
-              <a:t>实证完全支持理论预测形态：(a) FGLS 仿射线与分箱均值紧密契合；(b) 离散度 var/mean^2 从 5.32 降至 0.99；(c) 达峰期 88.9% 误差由基准漂移解释，控制后规模项仍显著为正；(d) 政策冲击与全国汇总（RelMSE=0.0348）实证验证了空间汇聚对偶收益。全套实证经受住了事前信息集与 213 项一致性回归检验。</a:t>
+              <a:t>实证完全支持理论预测形态：(a) FGLS 仿射线与分箱均值紧密契合；(b) 离散度 var/mean^2 从 5.32 降至 0.99；(c) 达峰期 88.9% 误差由基准漂移解释，控制后规模项仍显著为正；(d) 政策冲击与全国汇总（RelMSE=0.0348）验证了空间汇聚对偶收益。全套实证经受住事前信息集与 213 项一致性回归检验。</a:t>
             </a:r>
           </a:p>
         </p:txBody>
@@ -13392,7 +12941,7 @@
         <p:spPr>
           <a:xfrm>
             <a:off x="756000" y="1116000"/>
-            <a:ext cx="5032800" cy="216000"/>
+            <a:ext cx="5032800" cy="198000"/>
           </a:xfrm>
           <a:prstGeom prst="rect">
             <a:avLst/>
@@ -13427,8 +12976,8 @@
         </p:nvSpPr>
         <p:spPr>
           <a:xfrm>
-            <a:off x="756000" y="1367999"/>
-            <a:ext cx="5032800" cy="180000"/>
+            <a:off x="756000" y="1332000"/>
+            <a:ext cx="5032800" cy="162000"/>
           </a:xfrm>
           <a:prstGeom prst="rect">
             <a:avLst/>
@@ -13443,7 +12992,7 @@
           <a:lstStyle/>
           <a:p>
             <a:r>
-              <a:rPr sz="1019" b="1">
+              <a:rPr sz="1000" b="1">
                 <a:solidFill>
                   <a:srgbClr val="64748B"/>
                 </a:solidFill>
@@ -13463,8 +13012,8 @@
         </p:nvSpPr>
         <p:spPr>
           <a:xfrm>
-            <a:off x="756000" y="1602000"/>
-            <a:ext cx="5032800" cy="2088000"/>
+            <a:off x="756000" y="1548000"/>
+            <a:ext cx="5032800" cy="2286000"/>
           </a:xfrm>
           <a:prstGeom prst="roundRect">
             <a:avLst>
@@ -13497,8 +13046,8 @@
         </p:nvSpPr>
         <p:spPr>
           <a:xfrm>
-            <a:off x="864000" y="1674000"/>
-            <a:ext cx="4816800" cy="1944000"/>
+            <a:off x="864000" y="1602000"/>
+            <a:ext cx="4816800" cy="2178000"/>
           </a:xfrm>
           <a:prstGeom prst="rect">
             <a:avLst/>
@@ -13514,11 +13063,11 @@
           <a:p>
             <a:pPr>
               <a:lnSpc>
-                <a:spcPct val="120000"/>
-              </a:lnSpc>
-            </a:pPr>
-            <a:r>
-              <a:rPr sz="1019" b="1">
+                <a:spcPct val="115000"/>
+              </a:lnSpc>
+            </a:pPr>
+            <a:r>
+              <a:rPr sz="1000" b="1">
                 <a:solidFill>
                   <a:srgbClr val="1E293B"/>
                 </a:solidFill>
@@ -13529,7 +13078,7 @@
 </a:t>
             </a:r>
             <a:r>
-              <a:rPr sz="980">
+              <a:rPr sz="940">
                 <a:solidFill>
                   <a:srgbClr val="334155"/>
                 </a:solidFill>
@@ -13542,14 +13091,14 @@
           <a:p>
             <a:pPr>
               <a:lnSpc>
-                <a:spcPct val="120000"/>
+                <a:spcPct val="115000"/>
               </a:lnSpc>
               <a:spcBef>
-                <a:spcPts val="400"/>
+                <a:spcPts val="300"/>
               </a:spcBef>
             </a:pPr>
             <a:r>
-              <a:rPr sz="1019" b="1">
+              <a:rPr sz="1000" b="1">
                 <a:solidFill>
                   <a:srgbClr val="1E293B"/>
                 </a:solidFill>
@@ -13560,7 +13109,7 @@
 </a:t>
             </a:r>
             <a:r>
-              <a:rPr sz="980">
+              <a:rPr sz="940">
                 <a:solidFill>
                   <a:srgbClr val="334155"/>
                 </a:solidFill>
@@ -13573,14 +13122,14 @@
           <a:p>
             <a:pPr>
               <a:lnSpc>
-                <a:spcPct val="120000"/>
+                <a:spcPct val="115000"/>
               </a:lnSpc>
               <a:spcBef>
-                <a:spcPts val="400"/>
+                <a:spcPts val="300"/>
               </a:spcBef>
             </a:pPr>
             <a:r>
-              <a:rPr sz="1019" b="1">
+              <a:rPr sz="1000" b="1">
                 <a:solidFill>
                   <a:srgbClr val="1E293B"/>
                 </a:solidFill>
@@ -13591,7 +13140,7 @@
 </a:t>
             </a:r>
             <a:r>
-              <a:rPr sz="980">
+              <a:rPr sz="940">
                 <a:solidFill>
                   <a:srgbClr val="334155"/>
                 </a:solidFill>
@@ -13604,14 +13153,14 @@
           <a:p>
             <a:pPr>
               <a:lnSpc>
-                <a:spcPct val="120000"/>
+                <a:spcPct val="115000"/>
               </a:lnSpc>
               <a:spcBef>
-                <a:spcPts val="400"/>
+                <a:spcPts val="300"/>
               </a:spcBef>
             </a:pPr>
             <a:r>
-              <a:rPr sz="1019" b="1">
+              <a:rPr sz="1000" b="1">
                 <a:solidFill>
                   <a:srgbClr val="1E293B"/>
                 </a:solidFill>
@@ -13622,7 +13171,7 @@
 </a:t>
             </a:r>
             <a:r>
-              <a:rPr sz="980">
+              <a:rPr sz="940">
                 <a:solidFill>
                   <a:srgbClr val="334155"/>
                 </a:solidFill>
@@ -13642,8 +13191,8 @@
         </p:nvSpPr>
         <p:spPr>
           <a:xfrm>
-            <a:off x="756000" y="3762000"/>
-            <a:ext cx="5032800" cy="2466000"/>
+            <a:off x="756000" y="3905999"/>
+            <a:ext cx="5032800" cy="2322000"/>
           </a:xfrm>
           <a:prstGeom prst="roundRect">
             <a:avLst>
@@ -13676,8 +13225,8 @@
         </p:nvSpPr>
         <p:spPr>
           <a:xfrm>
-            <a:off x="900000" y="3834000"/>
-            <a:ext cx="4744800" cy="2322000"/>
+            <a:off x="900000" y="3977999"/>
+            <a:ext cx="4744800" cy="2178000"/>
           </a:xfrm>
           <a:prstGeom prst="rect">
             <a:avLst/>
@@ -13693,21 +13242,31 @@
           <a:p>
             <a:pPr>
               <a:lnSpc>
-                <a:spcPct val="122000"/>
-              </a:lnSpc>
-            </a:pPr>
-            <a:r>
-              <a:rPr sz="1100" b="1">
+                <a:spcPct val="115000"/>
+              </a:lnSpc>
+            </a:pPr>
+            <a:r>
+              <a:rPr sz="1080" b="1">
                 <a:solidFill>
                   <a:srgbClr val="1E3A8A"/>
                 </a:solidFill>
                 <a:latin typeface="Segoe UI"/>
                 <a:ea typeface="Microsoft YaHei"/>
               </a:rPr>
-              <a:t>【FluSight 验证对大论文的理论启示】  </a:t>
-            </a:r>
-            <a:r>
-              <a:rPr sz="980">
+              <a:t>【FluSight 验证对大论文的理论启示】</a:t>
+            </a:r>
+          </a:p>
+          <a:p>
+            <a:pPr>
+              <a:lnSpc>
+                <a:spcPct val="118000"/>
+              </a:lnSpc>
+              <a:spcBef>
+                <a:spcPts val="300"/>
+              </a:spcBef>
+            </a:pPr>
+            <a:r>
+              <a:rPr sz="950">
                 <a:solidFill>
                   <a:srgbClr val="334155"/>
                 </a:solidFill>
@@ -13762,7 +13321,7 @@
         <p:spPr>
           <a:xfrm>
             <a:off x="6400800" y="1116000"/>
-            <a:ext cx="5032800" cy="216000"/>
+            <a:ext cx="5032800" cy="198000"/>
           </a:xfrm>
           <a:prstGeom prst="rect">
             <a:avLst/>
@@ -13797,8 +13356,8 @@
         </p:nvSpPr>
         <p:spPr>
           <a:xfrm>
-            <a:off x="6400800" y="1367999"/>
-            <a:ext cx="5032800" cy="180000"/>
+            <a:off x="6400800" y="1332000"/>
+            <a:ext cx="5032800" cy="162000"/>
           </a:xfrm>
           <a:prstGeom prst="rect">
             <a:avLst/>
@@ -13813,7 +13372,7 @@
           <a:lstStyle/>
           <a:p>
             <a:r>
-              <a:rPr sz="1019">
+              <a:rPr sz="1000">
                 <a:solidFill>
                   <a:srgbClr val="64748B"/>
                 </a:solidFill>
@@ -13833,8 +13392,8 @@
         </p:nvSpPr>
         <p:spPr>
           <a:xfrm>
-            <a:off x="6400800" y="1602000"/>
-            <a:ext cx="5032800" cy="2088000"/>
+            <a:off x="6400800" y="1548000"/>
+            <a:ext cx="5032800" cy="2286000"/>
           </a:xfrm>
           <a:prstGeom prst="roundRect">
             <a:avLst>
@@ -13867,8 +13426,8 @@
         </p:nvSpPr>
         <p:spPr>
           <a:xfrm>
-            <a:off x="6508800" y="1674000"/>
-            <a:ext cx="4816800" cy="1944000"/>
+            <a:off x="6508800" y="1602000"/>
+            <a:ext cx="4816800" cy="2178000"/>
           </a:xfrm>
           <a:prstGeom prst="rect">
             <a:avLst/>
@@ -13884,11 +13443,11 @@
           <a:p>
             <a:pPr>
               <a:lnSpc>
-                <a:spcPct val="120000"/>
-              </a:lnSpc>
-            </a:pPr>
-            <a:r>
-              <a:rPr sz="1019" b="1">
+                <a:spcPct val="115000"/>
+              </a:lnSpc>
+            </a:pPr>
+            <a:r>
+              <a:rPr sz="1000" b="1">
                 <a:solidFill>
                   <a:srgbClr val="1E293B"/>
                 </a:solidFill>
@@ -13899,7 +13458,7 @@
 </a:t>
             </a:r>
             <a:r>
-              <a:rPr sz="980">
+              <a:rPr sz="940">
                 <a:solidFill>
                   <a:srgbClr val="334155"/>
                 </a:solidFill>
@@ -13912,14 +13471,14 @@
           <a:p>
             <a:pPr>
               <a:lnSpc>
-                <a:spcPct val="120000"/>
+                <a:spcPct val="115000"/>
               </a:lnSpc>
               <a:spcBef>
-                <a:spcPts val="400"/>
+                <a:spcPts val="300"/>
               </a:spcBef>
             </a:pPr>
             <a:r>
-              <a:rPr sz="1019" b="1">
+              <a:rPr sz="1000" b="1">
                 <a:solidFill>
                   <a:srgbClr val="1E293B"/>
                 </a:solidFill>
@@ -13930,7 +13489,7 @@
 </a:t>
             </a:r>
             <a:r>
-              <a:rPr sz="980">
+              <a:rPr sz="940">
                 <a:solidFill>
                   <a:srgbClr val="334155"/>
                 </a:solidFill>
@@ -13943,14 +13502,14 @@
           <a:p>
             <a:pPr>
               <a:lnSpc>
-                <a:spcPct val="120000"/>
+                <a:spcPct val="115000"/>
               </a:lnSpc>
               <a:spcBef>
-                <a:spcPts val="400"/>
+                <a:spcPts val="300"/>
               </a:spcBef>
             </a:pPr>
             <a:r>
-              <a:rPr sz="1019" b="1">
+              <a:rPr sz="1000" b="1">
                 <a:solidFill>
                   <a:srgbClr val="1E293B"/>
                 </a:solidFill>
@@ -13961,7 +13520,7 @@
 </a:t>
             </a:r>
             <a:r>
-              <a:rPr sz="980">
+              <a:rPr sz="940">
                 <a:solidFill>
                   <a:srgbClr val="334155"/>
                 </a:solidFill>
@@ -13974,14 +13533,14 @@
           <a:p>
             <a:pPr>
               <a:lnSpc>
-                <a:spcPct val="120000"/>
+                <a:spcPct val="115000"/>
               </a:lnSpc>
               <a:spcBef>
-                <a:spcPts val="400"/>
+                <a:spcPts val="300"/>
               </a:spcBef>
             </a:pPr>
             <a:r>
-              <a:rPr sz="1019" b="1">
+              <a:rPr sz="1000" b="1">
                 <a:solidFill>
                   <a:srgbClr val="1E293B"/>
                 </a:solidFill>
@@ -13992,7 +13551,7 @@
 </a:t>
             </a:r>
             <a:r>
-              <a:rPr sz="980">
+              <a:rPr sz="940">
                 <a:solidFill>
                   <a:srgbClr val="334155"/>
                 </a:solidFill>
@@ -14012,8 +13571,8 @@
         </p:nvSpPr>
         <p:spPr>
           <a:xfrm>
-            <a:off x="6400800" y="3762000"/>
-            <a:ext cx="5032800" cy="2466000"/>
+            <a:off x="6400800" y="3905999"/>
+            <a:ext cx="5032800" cy="2322000"/>
           </a:xfrm>
           <a:prstGeom prst="roundRect">
             <a:avLst>
@@ -14046,8 +13605,8 @@
         </p:nvSpPr>
         <p:spPr>
           <a:xfrm>
-            <a:off x="6508800" y="3834000"/>
-            <a:ext cx="4816800" cy="2322000"/>
+            <a:off x="6508800" y="3960000"/>
+            <a:ext cx="4816800" cy="2214000"/>
           </a:xfrm>
           <a:prstGeom prst="rect">
             <a:avLst/>
@@ -14067,7 +13626,7 @@
               </a:lnSpc>
             </a:pPr>
             <a:r>
-              <a:rPr sz="1150" b="1">
+              <a:rPr sz="1120" b="1">
                 <a:solidFill>
                   <a:srgbClr val="1E3A8A"/>
                 </a:solidFill>
@@ -14080,14 +13639,14 @@
           <a:p>
             <a:pPr>
               <a:lnSpc>
-                <a:spcPct val="122000"/>
+                <a:spcPct val="115000"/>
               </a:lnSpc>
               <a:spcBef>
-                <a:spcPts val="400"/>
+                <a:spcPts val="300"/>
               </a:spcBef>
             </a:pPr>
             <a:r>
-              <a:rPr sz="1019" b="1">
+              <a:rPr sz="1000" b="1">
                 <a:solidFill>
                   <a:srgbClr val="0F172A"/>
                 </a:solidFill>
@@ -14098,27 +13657,27 @@
 </a:t>
             </a:r>
             <a:r>
-              <a:rPr sz="980">
+              <a:rPr sz="940">
                 <a:solidFill>
                   <a:srgbClr val="334155"/>
                 </a:solidFill>
                 <a:latin typeface="Segoe UI"/>
                 <a:ea typeface="Microsoft YaHei"/>
               </a:rPr>
-              <a:t>  微观抽样与超传播噪声主导总方差。集中预算扩充哨点网络、提升抽样覆盖率与上报率，迅速压低抽样离散方差。</a:t>
+              <a:t>  微观抽样与超传播噪声主导总方差。集中预算扩充哨点网络、提高覆盖率与报告率，迅速压低抽样离散方差。</a:t>
             </a:r>
           </a:p>
           <a:p>
             <a:pPr>
               <a:lnSpc>
-                <a:spcPct val="122000"/>
+                <a:spcPct val="115000"/>
               </a:lnSpc>
               <a:spcBef>
-                <a:spcPts val="400"/>
+                <a:spcPts val="300"/>
               </a:spcBef>
             </a:pPr>
             <a:r>
-              <a:rPr sz="1019" b="1">
+              <a:rPr sz="1000" b="1">
                 <a:solidFill>
                   <a:srgbClr val="0F172A"/>
                 </a:solidFill>
@@ -14129,27 +13688,27 @@
 </a:t>
             </a:r>
             <a:r>
-              <a:rPr sz="980">
+              <a:rPr sz="940">
                 <a:solidFill>
                   <a:srgbClr val="334155"/>
                 </a:solidFill>
                 <a:latin typeface="Segoe UI"/>
                 <a:ea typeface="Microsoft YaHei"/>
               </a:rPr>
-              <a:t>  跨过内生平衡点后，总误差进入不可约环境噪声与模型失配主导的平台期。单纯增报病例边际收益锐减，果断转向控制环境协变量与集成预测。</a:t>
+              <a:t>  跨过内生平衡点后，总误差进入不可约环境噪声与模型失配主导平台期。单纯增报病例边际收益锐减，果断转向控制协变量与集成预测。</a:t>
             </a:r>
           </a:p>
           <a:p>
             <a:pPr>
               <a:lnSpc>
-                <a:spcPct val="122000"/>
+                <a:spcPct val="115000"/>
               </a:lnSpc>
               <a:spcBef>
-                <a:spcPts val="400"/>
+                <a:spcPts val="300"/>
               </a:spcBef>
             </a:pPr>
             <a:r>
-              <a:rPr sz="1019" b="1">
+              <a:rPr sz="1000" b="1">
                 <a:solidFill>
                   <a:srgbClr val="0F172A"/>
                 </a:solidFill>
@@ -14160,14 +13719,14 @@
 </a:t>
             </a:r>
             <a:r>
-              <a:rPr sz="980">
+              <a:rPr sz="940">
                 <a:solidFill>
                   <a:srgbClr val="334155"/>
                 </a:solidFill>
                 <a:latin typeface="Segoe UI"/>
                 <a:ea typeface="Microsoft YaHei"/>
               </a:rPr>
-              <a:t>  在进行爆发假设检验时，按目标病原体超离散度 k 精确测算 m_80%，避免盲目超额配置监测哨点导致资源闲置与低效。</a:t>
+              <a:t>  在进行爆发假设检验时，按目标病原体超离散度 k 精确测算 m_80%，避免盲目超额配置哨点导致资源闲置与低效。</a:t>
             </a:r>
           </a:p>
         </p:txBody>

</xml_diff>